<commit_message>
docs: assign Trend Analysis Agent to Nilanjan Das & Sagar Trimukhe
</commit_message>
<xml_diff>
--- a/CAPSTONE_PROJECT_PRESENTATION.pptx
+++ b/CAPSTONE_PROJECT_PRESENTATION.pptx
@@ -10016,7 +10016,7 @@
                         </a:defRPr>
                       </a:pPr>
                       <a:r>
-                        <a:t>270-stock NASDAQ universe, automated SEC EDGAR 10-K downloader, recursive table splitting, ChromaDB ticker isolation.</a:t>
+                        <a:t>Co-developed Trend &amp; Sentiment Analysis Agent. 270-stock NASDAQ universe, automated SEC EDGAR 10-K downloader, recursive table splitting, ChromaDB ticker isolation.</a:t>
                       </a:r>
                     </a:p>
                   </a:txBody>
@@ -10041,6 +10041,10 @@
                       </a:pPr>
                       <a:r>
                         <a:t>nasdaq_universe.py</a:t>
+                      </a:r>
+                      <a:br/>
+                      <a:r>
+                        <a:t>trend_analysis.py</a:t>
                       </a:r>
                       <a:br/>
                       <a:r>
@@ -14628,7 +14632,7 @@
               </a:defRPr>
             </a:pPr>
             <a:r>
-              <a:t>Lead: Shradha Gaikwad &amp; Sagar Trimukhe</a:t>
+              <a:t>Lead: Nilanjan Das &amp; Sagar Trimukhe</a:t>
             </a:r>
           </a:p>
           <a:p>

</xml_diff>

<commit_message>
fix: redesign cover slide — compact header, taller team cards with avatar+name+role+modules, left accent sidebar
</commit_message>
<xml_diff>
--- a/CAPSTONE_PROJECT_PRESENTATION.pptx
+++ b/CAPSTONE_PROJECT_PRESENTATION.pptx
@@ -3157,7 +3157,7 @@
         <p:spPr>
           <a:xfrm>
             <a:off x="0" y="0"/>
-            <a:ext cx="12191695" cy="73152"/>
+            <a:ext cx="320040" cy="6858000"/>
           </a:xfrm>
           <a:prstGeom prst="rect">
             <a:avLst/>
@@ -3199,8 +3199,8 @@
         </p:nvSpPr>
         <p:spPr>
           <a:xfrm>
-            <a:off x="731520" y="228600"/>
-            <a:ext cx="10698480" cy="365760"/>
+            <a:off x="594360" y="164592"/>
+            <a:ext cx="10972800" cy="292608"/>
           </a:xfrm>
           <a:prstGeom prst="rect">
             <a:avLst/>
@@ -3215,27 +3215,115 @@
           <a:p>
             <a:pPr algn="l"/>
             <a:r>
-              <a:rPr sz="950" b="1">
+              <a:rPr sz="850" b="1">
                 <a:solidFill>
                   <a:srgbClr val="38BDF8"/>
                 </a:solidFill>
                 <a:latin typeface="Arial"/>
               </a:rPr>
-              <a:t>AUTONOMOUS EQUITY INTELLIGENCE PLATFORM  ·  Platform Architecture</a:t>
-            </a:r>
-          </a:p>
-        </p:txBody>
-      </p:sp>
-      <p:sp>
-        <p:nvSpPr>
-          <p:cNvPr id="5" name="TextBox 4"/>
+              <a:t>AUTONOMOUS EQUITY INTELLIGENCE PLATFORM  ·  Platform Architecture  ·  ADVANCED PG CERTIFICATION IN AI ENGINEERING</a:t>
+            </a:r>
+          </a:p>
+        </p:txBody>
+      </p:sp>
+      <p:sp>
+        <p:nvSpPr>
+          <p:cNvPr id="5" name="Rectangle 4"/>
+          <p:cNvSpPr/>
+          <p:nvPr/>
+        </p:nvSpPr>
+        <p:spPr>
+          <a:xfrm>
+            <a:off x="731520" y="493776"/>
+            <a:ext cx="10134295" cy="22860"/>
+          </a:xfrm>
+          <a:prstGeom prst="rect">
+            <a:avLst/>
+          </a:prstGeom>
+          <a:solidFill>
+            <a:srgbClr val="1E304A"/>
+          </a:solidFill>
+          <a:ln>
+            <a:noFill/>
+          </a:ln>
+        </p:spPr>
+        <p:style>
+          <a:lnRef idx="1">
+            <a:schemeClr val="accent1"/>
+          </a:lnRef>
+          <a:fillRef idx="3">
+            <a:schemeClr val="accent1"/>
+          </a:fillRef>
+          <a:effectRef idx="2">
+            <a:schemeClr val="accent1"/>
+          </a:effectRef>
+          <a:fontRef idx="minor">
+            <a:schemeClr val="lt1"/>
+          </a:fontRef>
+        </p:style>
+        <p:txBody>
+          <a:bodyPr rtlCol="0" anchor="ctr"/>
+          <a:lstStyle/>
+          <a:p>
+            <a:pPr algn="ctr"/>
+          </a:p>
+        </p:txBody>
+      </p:sp>
+      <p:sp>
+        <p:nvSpPr>
+          <p:cNvPr id="6" name="Rounded Rectangle 5"/>
+          <p:cNvSpPr/>
+          <p:nvPr/>
+        </p:nvSpPr>
+        <p:spPr>
+          <a:xfrm>
+            <a:off x="594360" y="594360"/>
+            <a:ext cx="4754880" cy="347472"/>
+          </a:xfrm>
+          <a:prstGeom prst="roundRect">
+            <a:avLst/>
+          </a:prstGeom>
+          <a:solidFill>
+            <a:srgbClr val="0E182C"/>
+          </a:solidFill>
+          <a:ln w="9525">
+            <a:solidFill>
+              <a:srgbClr val="1E304A"/>
+            </a:solidFill>
+          </a:ln>
+        </p:spPr>
+        <p:style>
+          <a:lnRef idx="1">
+            <a:schemeClr val="accent1"/>
+          </a:lnRef>
+          <a:fillRef idx="3">
+            <a:schemeClr val="accent1"/>
+          </a:fillRef>
+          <a:effectRef idx="2">
+            <a:schemeClr val="accent1"/>
+          </a:effectRef>
+          <a:fontRef idx="minor">
+            <a:schemeClr val="lt1"/>
+          </a:fontRef>
+        </p:style>
+        <p:txBody>
+          <a:bodyPr rtlCol="0" anchor="ctr"/>
+          <a:lstStyle/>
+          <a:p>
+            <a:pPr algn="ctr"/>
+          </a:p>
+        </p:txBody>
+      </p:sp>
+      <p:sp>
+        <p:nvSpPr>
+          <p:cNvPr id="7" name="TextBox 6"/>
           <p:cNvSpPr txBox="1"/>
           <p:nvPr/>
         </p:nvSpPr>
         <p:spPr>
           <a:xfrm>
-            <a:off x="731520" y="960120"/>
-            <a:ext cx="10698480" cy="1325880"/>
+            <a:off x="621792" y="621792"/>
+            <a:ext cx="4700016" cy="274320"/>
           </a:xfrm>
           <a:prstGeom prst="rect">
             <a:avLst/>
@@ -3250,27 +3338,27 @@
           <a:p>
             <a:pPr algn="l"/>
             <a:r>
-              <a:rPr sz="4200" b="1">
-                <a:solidFill>
-                  <a:srgbClr val="F8FAFC"/>
-                </a:solidFill>
-                <a:latin typeface="Arial"/>
-              </a:rPr>
-              <a:t>AI Investment Research Assistant</a:t>
-            </a:r>
-          </a:p>
-        </p:txBody>
-      </p:sp>
-      <p:sp>
-        <p:nvSpPr>
-          <p:cNvPr id="6" name="TextBox 5"/>
+              <a:rPr sz="800" b="1">
+                <a:solidFill>
+                  <a:srgbClr val="94A3B8"/>
+                </a:solidFill>
+                <a:latin typeface="Arial"/>
+              </a:rPr>
+              <a:t>CAPSTONE FINAL DEFENSE  ·  QUANTITATIVE FINANCE DOMAIN  ·  FINANCE DOMAIN</a:t>
+            </a:r>
+          </a:p>
+        </p:txBody>
+      </p:sp>
+      <p:sp>
+        <p:nvSpPr>
+          <p:cNvPr id="8" name="TextBox 7"/>
           <p:cNvSpPr txBox="1"/>
           <p:nvPr/>
         </p:nvSpPr>
         <p:spPr>
           <a:xfrm>
-            <a:off x="731520" y="2331720"/>
-            <a:ext cx="8686800" cy="457200"/>
+            <a:off x="594360" y="1078992"/>
+            <a:ext cx="10972800" cy="1005840"/>
           </a:xfrm>
           <a:prstGeom prst="rect">
             <a:avLst/>
@@ -3285,27 +3373,27 @@
           <a:p>
             <a:pPr algn="l"/>
             <a:r>
-              <a:rPr sz="1300" b="0">
-                <a:solidFill>
-                  <a:srgbClr val="38BDF8"/>
-                </a:solidFill>
-                <a:latin typeface="Arial"/>
-              </a:rPr>
-              <a:t>Autonomous Multi-Agent Equity Research  ·  Human-in-the-Loop Governance  ·  AWS Cloud</a:t>
-            </a:r>
-          </a:p>
-        </p:txBody>
-      </p:sp>
-      <p:sp>
-        <p:nvSpPr>
-          <p:cNvPr id="7" name="Rectangle 6"/>
+              <a:rPr sz="3400" b="1">
+                <a:solidFill>
+                  <a:srgbClr val="F8FAFC"/>
+                </a:solidFill>
+                <a:latin typeface="Arial"/>
+              </a:rPr>
+              <a:t>AI Investment Research Assistant</a:t>
+            </a:r>
+          </a:p>
+        </p:txBody>
+      </p:sp>
+      <p:sp>
+        <p:nvSpPr>
+          <p:cNvPr id="9" name="Rectangle 8"/>
           <p:cNvSpPr/>
           <p:nvPr/>
         </p:nvSpPr>
         <p:spPr>
           <a:xfrm>
-            <a:off x="731520" y="2944368"/>
-            <a:ext cx="10728655" cy="22860"/>
+            <a:off x="594360" y="2121408"/>
+            <a:ext cx="6858000" cy="43891"/>
           </a:xfrm>
           <a:prstGeom prst="rect">
             <a:avLst/>
@@ -3341,57 +3429,14 @@
       </p:sp>
       <p:sp>
         <p:nvSpPr>
-          <p:cNvPr id="8" name="Rectangle 7"/>
-          <p:cNvSpPr/>
-          <p:nvPr/>
-        </p:nvSpPr>
-        <p:spPr>
-          <a:xfrm>
-            <a:off x="731520" y="3182112"/>
-            <a:ext cx="10728655" cy="475488"/>
-          </a:xfrm>
-          <a:prstGeom prst="rect">
-            <a:avLst/>
-          </a:prstGeom>
-          <a:solidFill>
-            <a:srgbClr val="0E1628"/>
-          </a:solidFill>
-          <a:ln>
-            <a:noFill/>
-          </a:ln>
-        </p:spPr>
-        <p:style>
-          <a:lnRef idx="1">
-            <a:schemeClr val="accent1"/>
-          </a:lnRef>
-          <a:fillRef idx="3">
-            <a:schemeClr val="accent1"/>
-          </a:fillRef>
-          <a:effectRef idx="2">
-            <a:schemeClr val="accent1"/>
-          </a:effectRef>
-          <a:fontRef idx="minor">
-            <a:schemeClr val="lt1"/>
-          </a:fontRef>
-        </p:style>
-        <p:txBody>
-          <a:bodyPr rtlCol="0" anchor="ctr"/>
-          <a:lstStyle/>
-          <a:p>
-            <a:pPr algn="ctr"/>
-          </a:p>
-        </p:txBody>
-      </p:sp>
-      <p:sp>
-        <p:nvSpPr>
-          <p:cNvPr id="9" name="TextBox 8"/>
+          <p:cNvPr id="10" name="TextBox 9"/>
           <p:cNvSpPr txBox="1"/>
           <p:nvPr/>
         </p:nvSpPr>
         <p:spPr>
           <a:xfrm>
-            <a:off x="731520" y="3227832"/>
-            <a:ext cx="10728655" cy="384048"/>
+            <a:off x="594360" y="2231136"/>
+            <a:ext cx="10515600" cy="384048"/>
           </a:xfrm>
           <a:prstGeom prst="rect">
             <a:avLst/>
@@ -3404,29 +3449,29 @@
           </a:bodyPr>
           <a:lstStyle/>
           <a:p>
-            <a:pPr algn="ctr"/>
-            <a:r>
-              <a:rPr sz="950" b="1">
+            <a:pPr algn="l"/>
+            <a:r>
+              <a:rPr sz="1250" b="0">
                 <a:solidFill>
                   <a:srgbClr val="94A3B8"/>
                 </a:solidFill>
                 <a:latin typeface="Arial"/>
               </a:rPr>
-              <a:t>CAPSTONE FINAL DEFENSE  ·  QUANTITATIVE FINANCE DOMAIN  ·  AUTONOMOUS EQUITY INTELLIGENCE PLATFORM</a:t>
-            </a:r>
-          </a:p>
-        </p:txBody>
-      </p:sp>
-      <p:sp>
-        <p:nvSpPr>
-          <p:cNvPr id="10" name="Rounded Rectangle 9"/>
+              <a:t>Autonomous Multi-Agent Equity Research   ·   Human-in-the-Loop Governance   ·   AWS Cloud</a:t>
+            </a:r>
+          </a:p>
+        </p:txBody>
+      </p:sp>
+      <p:sp>
+        <p:nvSpPr>
+          <p:cNvPr id="11" name="Rounded Rectangle 10"/>
           <p:cNvSpPr/>
           <p:nvPr/>
         </p:nvSpPr>
         <p:spPr>
           <a:xfrm>
-            <a:off x="731520" y="3840480"/>
-            <a:ext cx="2258568" cy="2286000"/>
+            <a:off x="594360" y="2788920"/>
+            <a:ext cx="2258568" cy="3840480"/>
           </a:xfrm>
           <a:prstGeom prst="roundRect">
             <a:avLst/>
@@ -3464,14 +3509,14 @@
       </p:sp>
       <p:sp>
         <p:nvSpPr>
-          <p:cNvPr id="11" name="Rectangle 10"/>
+          <p:cNvPr id="12" name="Rectangle 11"/>
           <p:cNvSpPr/>
           <p:nvPr/>
         </p:nvSpPr>
         <p:spPr>
           <a:xfrm>
-            <a:off x="731520" y="3840480"/>
-            <a:ext cx="2258568" cy="50292"/>
+            <a:off x="594360" y="2788920"/>
+            <a:ext cx="2258568" cy="54864"/>
           </a:xfrm>
           <a:prstGeom prst="rect">
             <a:avLst/>
@@ -3507,14 +3552,14 @@
       </p:sp>
       <p:sp>
         <p:nvSpPr>
-          <p:cNvPr id="12" name="Oval 11"/>
+          <p:cNvPr id="13" name="Oval 12"/>
           <p:cNvSpPr/>
           <p:nvPr/>
         </p:nvSpPr>
         <p:spPr>
           <a:xfrm>
-            <a:off x="1476756" y="4069080"/>
-            <a:ext cx="768096" cy="768096"/>
+            <a:off x="1220724" y="2990088"/>
+            <a:ext cx="1005840" cy="1005840"/>
           </a:xfrm>
           <a:prstGeom prst="ellipse">
             <a:avLst/>
@@ -3550,14 +3595,14 @@
       </p:sp>
       <p:sp>
         <p:nvSpPr>
-          <p:cNvPr id="13" name="TextBox 12"/>
+          <p:cNvPr id="14" name="TextBox 13"/>
           <p:cNvSpPr txBox="1"/>
           <p:nvPr/>
         </p:nvSpPr>
         <p:spPr>
           <a:xfrm>
-            <a:off x="1476756" y="4142232"/>
-            <a:ext cx="768096" cy="457200"/>
+            <a:off x="1220724" y="3099816"/>
+            <a:ext cx="1005840" cy="384048"/>
           </a:xfrm>
           <a:prstGeom prst="rect">
             <a:avLst/>
@@ -3572,7 +3617,7 @@
           <a:p>
             <a:pPr algn="ctr"/>
             <a:r>
-              <a:rPr sz="1400" b="1">
+              <a:rPr sz="1500" b="1">
                 <a:solidFill>
                   <a:srgbClr val="080C18"/>
                 </a:solidFill>
@@ -3585,14 +3630,57 @@
       </p:sp>
       <p:sp>
         <p:nvSpPr>
-          <p:cNvPr id="14" name="TextBox 13"/>
+          <p:cNvPr id="15" name="Rectangle 14"/>
+          <p:cNvSpPr/>
+          <p:nvPr/>
+        </p:nvSpPr>
+        <p:spPr>
+          <a:xfrm>
+            <a:off x="868680" y="4105656"/>
+            <a:ext cx="1709928" cy="18288"/>
+          </a:xfrm>
+          <a:prstGeom prst="rect">
+            <a:avLst/>
+          </a:prstGeom>
+          <a:solidFill>
+            <a:srgbClr val="1E304A"/>
+          </a:solidFill>
+          <a:ln>
+            <a:noFill/>
+          </a:ln>
+        </p:spPr>
+        <p:style>
+          <a:lnRef idx="1">
+            <a:schemeClr val="accent1"/>
+          </a:lnRef>
+          <a:fillRef idx="3">
+            <a:schemeClr val="accent1"/>
+          </a:fillRef>
+          <a:effectRef idx="2">
+            <a:schemeClr val="accent1"/>
+          </a:effectRef>
+          <a:fontRef idx="minor">
+            <a:schemeClr val="lt1"/>
+          </a:fontRef>
+        </p:style>
+        <p:txBody>
+          <a:bodyPr rtlCol="0" anchor="ctr"/>
+          <a:lstStyle/>
+          <a:p>
+            <a:pPr algn="ctr"/>
+          </a:p>
+        </p:txBody>
+      </p:sp>
+      <p:sp>
+        <p:nvSpPr>
+          <p:cNvPr id="16" name="TextBox 15"/>
           <p:cNvSpPr txBox="1"/>
           <p:nvPr/>
         </p:nvSpPr>
         <p:spPr>
           <a:xfrm>
-            <a:off x="822960" y="4956048"/>
-            <a:ext cx="2075688" cy="411480"/>
+            <a:off x="685800" y="4233672"/>
+            <a:ext cx="2075688" cy="384048"/>
           </a:xfrm>
           <a:prstGeom prst="rect">
             <a:avLst/>
@@ -3607,7 +3695,7 @@
           <a:p>
             <a:pPr algn="ctr"/>
             <a:r>
-              <a:rPr sz="1100" b="1">
+              <a:rPr sz="1150" b="1">
                 <a:solidFill>
                   <a:srgbClr val="F8FAFC"/>
                 </a:solidFill>
@@ -3620,14 +3708,14 @@
       </p:sp>
       <p:sp>
         <p:nvSpPr>
-          <p:cNvPr id="15" name="TextBox 14"/>
+          <p:cNvPr id="17" name="TextBox 16"/>
           <p:cNvSpPr txBox="1"/>
           <p:nvPr/>
         </p:nvSpPr>
         <p:spPr>
           <a:xfrm>
-            <a:off x="822960" y="5349240"/>
-            <a:ext cx="2075688" cy="640080"/>
+            <a:off x="685800" y="4617720"/>
+            <a:ext cx="2075688" cy="320040"/>
           </a:xfrm>
           <a:prstGeom prst="rect">
             <a:avLst/>
@@ -3655,14 +3743,92 @@
       </p:sp>
       <p:sp>
         <p:nvSpPr>
-          <p:cNvPr id="16" name="Rounded Rectangle 15"/>
+          <p:cNvPr id="18" name="Rectangle 17"/>
           <p:cNvSpPr/>
           <p:nvPr/>
         </p:nvSpPr>
         <p:spPr>
           <a:xfrm>
-            <a:off x="3054096" y="3840480"/>
-            <a:ext cx="2258568" cy="2286000"/>
+            <a:off x="868680" y="4983480"/>
+            <a:ext cx="1709928" cy="18288"/>
+          </a:xfrm>
+          <a:prstGeom prst="rect">
+            <a:avLst/>
+          </a:prstGeom>
+          <a:solidFill>
+            <a:srgbClr val="1E304A"/>
+          </a:solidFill>
+          <a:ln>
+            <a:noFill/>
+          </a:ln>
+        </p:spPr>
+        <p:style>
+          <a:lnRef idx="1">
+            <a:schemeClr val="accent1"/>
+          </a:lnRef>
+          <a:fillRef idx="3">
+            <a:schemeClr val="accent1"/>
+          </a:fillRef>
+          <a:effectRef idx="2">
+            <a:schemeClr val="accent1"/>
+          </a:effectRef>
+          <a:fontRef idx="minor">
+            <a:schemeClr val="lt1"/>
+          </a:fontRef>
+        </p:style>
+        <p:txBody>
+          <a:bodyPr rtlCol="0" anchor="ctr"/>
+          <a:lstStyle/>
+          <a:p>
+            <a:pPr algn="ctr"/>
+          </a:p>
+        </p:txBody>
+      </p:sp>
+      <p:sp>
+        <p:nvSpPr>
+          <p:cNvPr id="19" name="TextBox 18"/>
+          <p:cNvSpPr txBox="1"/>
+          <p:nvPr/>
+        </p:nvSpPr>
+        <p:spPr>
+          <a:xfrm>
+            <a:off x="731520" y="5111496"/>
+            <a:ext cx="1984248" cy="640080"/>
+          </a:xfrm>
+          <a:prstGeom prst="rect">
+            <a:avLst/>
+          </a:prstGeom>
+          <a:noFill/>
+        </p:spPr>
+        <p:txBody>
+          <a:bodyPr wrap="square" lIns="0" tIns="0" rIns="0" bIns="0">
+            <a:spAutoFit/>
+          </a:bodyPr>
+          <a:lstStyle/>
+          <a:p>
+            <a:pPr algn="ctr"/>
+            <a:r>
+              <a:rPr sz="850" b="0">
+                <a:solidFill>
+                  <a:srgbClr val="475569"/>
+                </a:solidFill>
+                <a:latin typeface="Arial"/>
+              </a:rPr>
+              <a:t>LangGraph DAG · AWS EC2 · Docker</a:t>
+            </a:r>
+          </a:p>
+        </p:txBody>
+      </p:sp>
+      <p:sp>
+        <p:nvSpPr>
+          <p:cNvPr id="20" name="Rounded Rectangle 19"/>
+          <p:cNvSpPr/>
+          <p:nvPr/>
+        </p:nvSpPr>
+        <p:spPr>
+          <a:xfrm>
+            <a:off x="2916936" y="2788920"/>
+            <a:ext cx="2258568" cy="3840480"/>
           </a:xfrm>
           <a:prstGeom prst="roundRect">
             <a:avLst/>
@@ -3700,14 +3866,14 @@
       </p:sp>
       <p:sp>
         <p:nvSpPr>
-          <p:cNvPr id="17" name="Rectangle 16"/>
+          <p:cNvPr id="21" name="Rectangle 20"/>
           <p:cNvSpPr/>
           <p:nvPr/>
         </p:nvSpPr>
         <p:spPr>
           <a:xfrm>
-            <a:off x="3054096" y="3840480"/>
-            <a:ext cx="2258568" cy="50292"/>
+            <a:off x="2916936" y="2788920"/>
+            <a:ext cx="2258568" cy="54864"/>
           </a:xfrm>
           <a:prstGeom prst="rect">
             <a:avLst/>
@@ -3743,14 +3909,14 @@
       </p:sp>
       <p:sp>
         <p:nvSpPr>
-          <p:cNvPr id="18" name="Oval 17"/>
+          <p:cNvPr id="22" name="Oval 21"/>
           <p:cNvSpPr/>
           <p:nvPr/>
         </p:nvSpPr>
         <p:spPr>
           <a:xfrm>
-            <a:off x="3799332" y="4069080"/>
-            <a:ext cx="768096" cy="768096"/>
+            <a:off x="3543300" y="2990088"/>
+            <a:ext cx="1005840" cy="1005840"/>
           </a:xfrm>
           <a:prstGeom prst="ellipse">
             <a:avLst/>
@@ -3786,14 +3952,14 @@
       </p:sp>
       <p:sp>
         <p:nvSpPr>
-          <p:cNvPr id="19" name="TextBox 18"/>
+          <p:cNvPr id="23" name="TextBox 22"/>
           <p:cNvSpPr txBox="1"/>
           <p:nvPr/>
         </p:nvSpPr>
         <p:spPr>
           <a:xfrm>
-            <a:off x="3799332" y="4142232"/>
-            <a:ext cx="768096" cy="457200"/>
+            <a:off x="3543300" y="3099816"/>
+            <a:ext cx="1005840" cy="384048"/>
           </a:xfrm>
           <a:prstGeom prst="rect">
             <a:avLst/>
@@ -3808,7 +3974,7 @@
           <a:p>
             <a:pPr algn="ctr"/>
             <a:r>
-              <a:rPr sz="1400" b="1">
+              <a:rPr sz="1500" b="1">
                 <a:solidFill>
                   <a:srgbClr val="080C18"/>
                 </a:solidFill>
@@ -3821,14 +3987,57 @@
       </p:sp>
       <p:sp>
         <p:nvSpPr>
-          <p:cNvPr id="20" name="TextBox 19"/>
+          <p:cNvPr id="24" name="Rectangle 23"/>
+          <p:cNvSpPr/>
+          <p:nvPr/>
+        </p:nvSpPr>
+        <p:spPr>
+          <a:xfrm>
+            <a:off x="3191256" y="4105656"/>
+            <a:ext cx="1709928" cy="18288"/>
+          </a:xfrm>
+          <a:prstGeom prst="rect">
+            <a:avLst/>
+          </a:prstGeom>
+          <a:solidFill>
+            <a:srgbClr val="1E304A"/>
+          </a:solidFill>
+          <a:ln>
+            <a:noFill/>
+          </a:ln>
+        </p:spPr>
+        <p:style>
+          <a:lnRef idx="1">
+            <a:schemeClr val="accent1"/>
+          </a:lnRef>
+          <a:fillRef idx="3">
+            <a:schemeClr val="accent1"/>
+          </a:fillRef>
+          <a:effectRef idx="2">
+            <a:schemeClr val="accent1"/>
+          </a:effectRef>
+          <a:fontRef idx="minor">
+            <a:schemeClr val="lt1"/>
+          </a:fontRef>
+        </p:style>
+        <p:txBody>
+          <a:bodyPr rtlCol="0" anchor="ctr"/>
+          <a:lstStyle/>
+          <a:p>
+            <a:pPr algn="ctr"/>
+          </a:p>
+        </p:txBody>
+      </p:sp>
+      <p:sp>
+        <p:nvSpPr>
+          <p:cNvPr id="25" name="TextBox 24"/>
           <p:cNvSpPr txBox="1"/>
           <p:nvPr/>
         </p:nvSpPr>
         <p:spPr>
           <a:xfrm>
-            <a:off x="3145536" y="4956048"/>
-            <a:ext cx="2075688" cy="411480"/>
+            <a:off x="3008376" y="4233672"/>
+            <a:ext cx="2075688" cy="384048"/>
           </a:xfrm>
           <a:prstGeom prst="rect">
             <a:avLst/>
@@ -3843,7 +4052,7 @@
           <a:p>
             <a:pPr algn="ctr"/>
             <a:r>
-              <a:rPr sz="1100" b="1">
+              <a:rPr sz="1150" b="1">
                 <a:solidFill>
                   <a:srgbClr val="F8FAFC"/>
                 </a:solidFill>
@@ -3856,14 +4065,14 @@
       </p:sp>
       <p:sp>
         <p:nvSpPr>
-          <p:cNvPr id="21" name="TextBox 20"/>
+          <p:cNvPr id="26" name="TextBox 25"/>
           <p:cNvSpPr txBox="1"/>
           <p:nvPr/>
         </p:nvSpPr>
         <p:spPr>
           <a:xfrm>
-            <a:off x="3145536" y="5349240"/>
-            <a:ext cx="2075688" cy="640080"/>
+            <a:off x="3008376" y="4617720"/>
+            <a:ext cx="2075688" cy="320040"/>
           </a:xfrm>
           <a:prstGeom prst="rect">
             <a:avLst/>
@@ -3891,14 +4100,92 @@
       </p:sp>
       <p:sp>
         <p:nvSpPr>
-          <p:cNvPr id="22" name="Rounded Rectangle 21"/>
+          <p:cNvPr id="27" name="Rectangle 26"/>
           <p:cNvSpPr/>
           <p:nvPr/>
         </p:nvSpPr>
         <p:spPr>
           <a:xfrm>
-            <a:off x="5376672" y="3840480"/>
-            <a:ext cx="2258568" cy="2286000"/>
+            <a:off x="3191256" y="4983480"/>
+            <a:ext cx="1709928" cy="18288"/>
+          </a:xfrm>
+          <a:prstGeom prst="rect">
+            <a:avLst/>
+          </a:prstGeom>
+          <a:solidFill>
+            <a:srgbClr val="1E304A"/>
+          </a:solidFill>
+          <a:ln>
+            <a:noFill/>
+          </a:ln>
+        </p:spPr>
+        <p:style>
+          <a:lnRef idx="1">
+            <a:schemeClr val="accent1"/>
+          </a:lnRef>
+          <a:fillRef idx="3">
+            <a:schemeClr val="accent1"/>
+          </a:fillRef>
+          <a:effectRef idx="2">
+            <a:schemeClr val="accent1"/>
+          </a:effectRef>
+          <a:fontRef idx="minor">
+            <a:schemeClr val="lt1"/>
+          </a:fontRef>
+        </p:style>
+        <p:txBody>
+          <a:bodyPr rtlCol="0" anchor="ctr"/>
+          <a:lstStyle/>
+          <a:p>
+            <a:pPr algn="ctr"/>
+          </a:p>
+        </p:txBody>
+      </p:sp>
+      <p:sp>
+        <p:nvSpPr>
+          <p:cNvPr id="28" name="TextBox 27"/>
+          <p:cNvSpPr txBox="1"/>
+          <p:nvPr/>
+        </p:nvSpPr>
+        <p:spPr>
+          <a:xfrm>
+            <a:off x="3054096" y="5111496"/>
+            <a:ext cx="1984248" cy="640080"/>
+          </a:xfrm>
+          <a:prstGeom prst="rect">
+            <a:avLst/>
+          </a:prstGeom>
+          <a:noFill/>
+        </p:spPr>
+        <p:txBody>
+          <a:bodyPr wrap="square" lIns="0" tIns="0" rIns="0" bIns="0">
+            <a:spAutoFit/>
+          </a:bodyPr>
+          <a:lstStyle/>
+          <a:p>
+            <a:pPr algn="ctr"/>
+            <a:r>
+              <a:rPr sz="850" b="0">
+                <a:solidFill>
+                  <a:srgbClr val="475569"/>
+                </a:solidFill>
+                <a:latin typeface="Arial"/>
+              </a:rPr>
+              <a:t>Market Research · Summary · Schemas</a:t>
+            </a:r>
+          </a:p>
+        </p:txBody>
+      </p:sp>
+      <p:sp>
+        <p:nvSpPr>
+          <p:cNvPr id="29" name="Rounded Rectangle 28"/>
+          <p:cNvSpPr/>
+          <p:nvPr/>
+        </p:nvSpPr>
+        <p:spPr>
+          <a:xfrm>
+            <a:off x="5239512" y="2788920"/>
+            <a:ext cx="2258568" cy="3840480"/>
           </a:xfrm>
           <a:prstGeom prst="roundRect">
             <a:avLst/>
@@ -3936,14 +4223,14 @@
       </p:sp>
       <p:sp>
         <p:nvSpPr>
-          <p:cNvPr id="23" name="Rectangle 22"/>
+          <p:cNvPr id="30" name="Rectangle 29"/>
           <p:cNvSpPr/>
           <p:nvPr/>
         </p:nvSpPr>
         <p:spPr>
           <a:xfrm>
-            <a:off x="5376672" y="3840480"/>
-            <a:ext cx="2258568" cy="50292"/>
+            <a:off x="5239512" y="2788920"/>
+            <a:ext cx="2258568" cy="54864"/>
           </a:xfrm>
           <a:prstGeom prst="rect">
             <a:avLst/>
@@ -3979,14 +4266,14 @@
       </p:sp>
       <p:sp>
         <p:nvSpPr>
-          <p:cNvPr id="24" name="Oval 23"/>
+          <p:cNvPr id="31" name="Oval 30"/>
           <p:cNvSpPr/>
           <p:nvPr/>
         </p:nvSpPr>
         <p:spPr>
           <a:xfrm>
-            <a:off x="6121908" y="4069080"/>
-            <a:ext cx="768096" cy="768096"/>
+            <a:off x="5865876" y="2990088"/>
+            <a:ext cx="1005840" cy="1005840"/>
           </a:xfrm>
           <a:prstGeom prst="ellipse">
             <a:avLst/>
@@ -4022,14 +4309,14 @@
       </p:sp>
       <p:sp>
         <p:nvSpPr>
-          <p:cNvPr id="25" name="TextBox 24"/>
+          <p:cNvPr id="32" name="TextBox 31"/>
           <p:cNvSpPr txBox="1"/>
           <p:nvPr/>
         </p:nvSpPr>
         <p:spPr>
           <a:xfrm>
-            <a:off x="6121908" y="4142232"/>
-            <a:ext cx="768096" cy="457200"/>
+            <a:off x="5865876" y="3099816"/>
+            <a:ext cx="1005840" cy="384048"/>
           </a:xfrm>
           <a:prstGeom prst="rect">
             <a:avLst/>
@@ -4044,7 +4331,7 @@
           <a:p>
             <a:pPr algn="ctr"/>
             <a:r>
-              <a:rPr sz="1400" b="1">
+              <a:rPr sz="1500" b="1">
                 <a:solidFill>
                   <a:srgbClr val="080C18"/>
                 </a:solidFill>
@@ -4057,14 +4344,57 @@
       </p:sp>
       <p:sp>
         <p:nvSpPr>
-          <p:cNvPr id="26" name="TextBox 25"/>
+          <p:cNvPr id="33" name="Rectangle 32"/>
+          <p:cNvSpPr/>
+          <p:nvPr/>
+        </p:nvSpPr>
+        <p:spPr>
+          <a:xfrm>
+            <a:off x="5513832" y="4105656"/>
+            <a:ext cx="1709928" cy="18288"/>
+          </a:xfrm>
+          <a:prstGeom prst="rect">
+            <a:avLst/>
+          </a:prstGeom>
+          <a:solidFill>
+            <a:srgbClr val="1E304A"/>
+          </a:solidFill>
+          <a:ln>
+            <a:noFill/>
+          </a:ln>
+        </p:spPr>
+        <p:style>
+          <a:lnRef idx="1">
+            <a:schemeClr val="accent1"/>
+          </a:lnRef>
+          <a:fillRef idx="3">
+            <a:schemeClr val="accent1"/>
+          </a:fillRef>
+          <a:effectRef idx="2">
+            <a:schemeClr val="accent1"/>
+          </a:effectRef>
+          <a:fontRef idx="minor">
+            <a:schemeClr val="lt1"/>
+          </a:fontRef>
+        </p:style>
+        <p:txBody>
+          <a:bodyPr rtlCol="0" anchor="ctr"/>
+          <a:lstStyle/>
+          <a:p>
+            <a:pPr algn="ctr"/>
+          </a:p>
+        </p:txBody>
+      </p:sp>
+      <p:sp>
+        <p:nvSpPr>
+          <p:cNvPr id="34" name="TextBox 33"/>
           <p:cNvSpPr txBox="1"/>
           <p:nvPr/>
         </p:nvSpPr>
         <p:spPr>
           <a:xfrm>
-            <a:off x="5468112" y="4956048"/>
-            <a:ext cx="2075688" cy="411480"/>
+            <a:off x="5330952" y="4233672"/>
+            <a:ext cx="2075688" cy="384048"/>
           </a:xfrm>
           <a:prstGeom prst="rect">
             <a:avLst/>
@@ -4079,7 +4409,7 @@
           <a:p>
             <a:pPr algn="ctr"/>
             <a:r>
-              <a:rPr sz="1100" b="1">
+              <a:rPr sz="1150" b="1">
                 <a:solidFill>
                   <a:srgbClr val="F8FAFC"/>
                 </a:solidFill>
@@ -4092,14 +4422,14 @@
       </p:sp>
       <p:sp>
         <p:nvSpPr>
-          <p:cNvPr id="27" name="TextBox 26"/>
+          <p:cNvPr id="35" name="TextBox 34"/>
           <p:cNvSpPr txBox="1"/>
           <p:nvPr/>
         </p:nvSpPr>
         <p:spPr>
           <a:xfrm>
-            <a:off x="5468112" y="5349240"/>
-            <a:ext cx="2075688" cy="640080"/>
+            <a:off x="5330952" y="4617720"/>
+            <a:ext cx="2075688" cy="320040"/>
           </a:xfrm>
           <a:prstGeom prst="rect">
             <a:avLst/>
@@ -4127,14 +4457,92 @@
       </p:sp>
       <p:sp>
         <p:nvSpPr>
-          <p:cNvPr id="28" name="Rounded Rectangle 27"/>
+          <p:cNvPr id="36" name="Rectangle 35"/>
           <p:cNvSpPr/>
           <p:nvPr/>
         </p:nvSpPr>
         <p:spPr>
           <a:xfrm>
-            <a:off x="7699248" y="3840480"/>
-            <a:ext cx="2258568" cy="2286000"/>
+            <a:off x="5513832" y="4983480"/>
+            <a:ext cx="1709928" cy="18288"/>
+          </a:xfrm>
+          <a:prstGeom prst="rect">
+            <a:avLst/>
+          </a:prstGeom>
+          <a:solidFill>
+            <a:srgbClr val="1E304A"/>
+          </a:solidFill>
+          <a:ln>
+            <a:noFill/>
+          </a:ln>
+        </p:spPr>
+        <p:style>
+          <a:lnRef idx="1">
+            <a:schemeClr val="accent1"/>
+          </a:lnRef>
+          <a:fillRef idx="3">
+            <a:schemeClr val="accent1"/>
+          </a:fillRef>
+          <a:effectRef idx="2">
+            <a:schemeClr val="accent1"/>
+          </a:effectRef>
+          <a:fontRef idx="minor">
+            <a:schemeClr val="lt1"/>
+          </a:fontRef>
+        </p:style>
+        <p:txBody>
+          <a:bodyPr rtlCol="0" anchor="ctr"/>
+          <a:lstStyle/>
+          <a:p>
+            <a:pPr algn="ctr"/>
+          </a:p>
+        </p:txBody>
+      </p:sp>
+      <p:sp>
+        <p:nvSpPr>
+          <p:cNvPr id="37" name="TextBox 36"/>
+          <p:cNvSpPr txBox="1"/>
+          <p:nvPr/>
+        </p:nvSpPr>
+        <p:spPr>
+          <a:xfrm>
+            <a:off x="5376672" y="5111496"/>
+            <a:ext cx="1984248" cy="640080"/>
+          </a:xfrm>
+          <a:prstGeom prst="rect">
+            <a:avLst/>
+          </a:prstGeom>
+          <a:noFill/>
+        </p:spPr>
+        <p:txBody>
+          <a:bodyPr wrap="square" lIns="0" tIns="0" rIns="0" bIns="0">
+            <a:spAutoFit/>
+          </a:bodyPr>
+          <a:lstStyle/>
+          <a:p>
+            <a:pPr algn="ctr"/>
+            <a:r>
+              <a:rPr sz="850" b="0">
+                <a:solidFill>
+                  <a:srgbClr val="475569"/>
+                </a:solidFill>
+                <a:latin typeface="Arial"/>
+              </a:rPr>
+              <a:t>Streamlit UI · Docker · S3 Export</a:t>
+            </a:r>
+          </a:p>
+        </p:txBody>
+      </p:sp>
+      <p:sp>
+        <p:nvSpPr>
+          <p:cNvPr id="38" name="Rounded Rectangle 37"/>
+          <p:cNvSpPr/>
+          <p:nvPr/>
+        </p:nvSpPr>
+        <p:spPr>
+          <a:xfrm>
+            <a:off x="7562088" y="2788920"/>
+            <a:ext cx="2258568" cy="3840480"/>
           </a:xfrm>
           <a:prstGeom prst="roundRect">
             <a:avLst/>
@@ -4172,14 +4580,14 @@
       </p:sp>
       <p:sp>
         <p:nvSpPr>
-          <p:cNvPr id="29" name="Rectangle 28"/>
+          <p:cNvPr id="39" name="Rectangle 38"/>
           <p:cNvSpPr/>
           <p:nvPr/>
         </p:nvSpPr>
         <p:spPr>
           <a:xfrm>
-            <a:off x="7699248" y="3840480"/>
-            <a:ext cx="2258568" cy="50292"/>
+            <a:off x="7562088" y="2788920"/>
+            <a:ext cx="2258568" cy="54864"/>
           </a:xfrm>
           <a:prstGeom prst="rect">
             <a:avLst/>
@@ -4215,14 +4623,14 @@
       </p:sp>
       <p:sp>
         <p:nvSpPr>
-          <p:cNvPr id="30" name="Oval 29"/>
+          <p:cNvPr id="40" name="Oval 39"/>
           <p:cNvSpPr/>
           <p:nvPr/>
         </p:nvSpPr>
         <p:spPr>
           <a:xfrm>
-            <a:off x="8444484" y="4069080"/>
-            <a:ext cx="768096" cy="768096"/>
+            <a:off x="8188452" y="2990088"/>
+            <a:ext cx="1005840" cy="1005840"/>
           </a:xfrm>
           <a:prstGeom prst="ellipse">
             <a:avLst/>
@@ -4258,14 +4666,14 @@
       </p:sp>
       <p:sp>
         <p:nvSpPr>
-          <p:cNvPr id="31" name="TextBox 30"/>
+          <p:cNvPr id="41" name="TextBox 40"/>
           <p:cNvSpPr txBox="1"/>
           <p:nvPr/>
         </p:nvSpPr>
         <p:spPr>
           <a:xfrm>
-            <a:off x="8444484" y="4142232"/>
-            <a:ext cx="768096" cy="457200"/>
+            <a:off x="8188452" y="3099816"/>
+            <a:ext cx="1005840" cy="384048"/>
           </a:xfrm>
           <a:prstGeom prst="rect">
             <a:avLst/>
@@ -4280,7 +4688,7 @@
           <a:p>
             <a:pPr algn="ctr"/>
             <a:r>
-              <a:rPr sz="1400" b="1">
+              <a:rPr sz="1500" b="1">
                 <a:solidFill>
                   <a:srgbClr val="080C18"/>
                 </a:solidFill>
@@ -4293,14 +4701,57 @@
       </p:sp>
       <p:sp>
         <p:nvSpPr>
-          <p:cNvPr id="32" name="TextBox 31"/>
+          <p:cNvPr id="42" name="Rectangle 41"/>
+          <p:cNvSpPr/>
+          <p:nvPr/>
+        </p:nvSpPr>
+        <p:spPr>
+          <a:xfrm>
+            <a:off x="7836408" y="4105656"/>
+            <a:ext cx="1709928" cy="18288"/>
+          </a:xfrm>
+          <a:prstGeom prst="rect">
+            <a:avLst/>
+          </a:prstGeom>
+          <a:solidFill>
+            <a:srgbClr val="1E304A"/>
+          </a:solidFill>
+          <a:ln>
+            <a:noFill/>
+          </a:ln>
+        </p:spPr>
+        <p:style>
+          <a:lnRef idx="1">
+            <a:schemeClr val="accent1"/>
+          </a:lnRef>
+          <a:fillRef idx="3">
+            <a:schemeClr val="accent1"/>
+          </a:fillRef>
+          <a:effectRef idx="2">
+            <a:schemeClr val="accent1"/>
+          </a:effectRef>
+          <a:fontRef idx="minor">
+            <a:schemeClr val="lt1"/>
+          </a:fontRef>
+        </p:style>
+        <p:txBody>
+          <a:bodyPr rtlCol="0" anchor="ctr"/>
+          <a:lstStyle/>
+          <a:p>
+            <a:pPr algn="ctr"/>
+          </a:p>
+        </p:txBody>
+      </p:sp>
+      <p:sp>
+        <p:nvSpPr>
+          <p:cNvPr id="43" name="TextBox 42"/>
           <p:cNvSpPr txBox="1"/>
           <p:nvPr/>
         </p:nvSpPr>
         <p:spPr>
           <a:xfrm>
-            <a:off x="7790688" y="4956048"/>
-            <a:ext cx="2075688" cy="411480"/>
+            <a:off x="7653528" y="4233672"/>
+            <a:ext cx="2075688" cy="384048"/>
           </a:xfrm>
           <a:prstGeom prst="rect">
             <a:avLst/>
@@ -4315,7 +4766,7 @@
           <a:p>
             <a:pPr algn="ctr"/>
             <a:r>
-              <a:rPr sz="1100" b="1">
+              <a:rPr sz="1150" b="1">
                 <a:solidFill>
                   <a:srgbClr val="F8FAFC"/>
                 </a:solidFill>
@@ -4328,14 +4779,14 @@
       </p:sp>
       <p:sp>
         <p:nvSpPr>
-          <p:cNvPr id="33" name="TextBox 32"/>
+          <p:cNvPr id="44" name="TextBox 43"/>
           <p:cNvSpPr txBox="1"/>
           <p:nvPr/>
         </p:nvSpPr>
         <p:spPr>
           <a:xfrm>
-            <a:off x="7790688" y="5349240"/>
-            <a:ext cx="2075688" cy="640080"/>
+            <a:off x="7653528" y="4617720"/>
+            <a:ext cx="2075688" cy="320040"/>
           </a:xfrm>
           <a:prstGeom prst="rect">
             <a:avLst/>
@@ -4363,14 +4814,92 @@
       </p:sp>
       <p:sp>
         <p:nvSpPr>
-          <p:cNvPr id="34" name="Rounded Rectangle 33"/>
+          <p:cNvPr id="45" name="Rectangle 44"/>
           <p:cNvSpPr/>
           <p:nvPr/>
         </p:nvSpPr>
         <p:spPr>
           <a:xfrm>
-            <a:off x="10021824" y="3840480"/>
-            <a:ext cx="2258568" cy="2286000"/>
+            <a:off x="7836408" y="4983480"/>
+            <a:ext cx="1709928" cy="18288"/>
+          </a:xfrm>
+          <a:prstGeom prst="rect">
+            <a:avLst/>
+          </a:prstGeom>
+          <a:solidFill>
+            <a:srgbClr val="1E304A"/>
+          </a:solidFill>
+          <a:ln>
+            <a:noFill/>
+          </a:ln>
+        </p:spPr>
+        <p:style>
+          <a:lnRef idx="1">
+            <a:schemeClr val="accent1"/>
+          </a:lnRef>
+          <a:fillRef idx="3">
+            <a:schemeClr val="accent1"/>
+          </a:fillRef>
+          <a:effectRef idx="2">
+            <a:schemeClr val="accent1"/>
+          </a:effectRef>
+          <a:fontRef idx="minor">
+            <a:schemeClr val="lt1"/>
+          </a:fontRef>
+        </p:style>
+        <p:txBody>
+          <a:bodyPr rtlCol="0" anchor="ctr"/>
+          <a:lstStyle/>
+          <a:p>
+            <a:pPr algn="ctr"/>
+          </a:p>
+        </p:txBody>
+      </p:sp>
+      <p:sp>
+        <p:nvSpPr>
+          <p:cNvPr id="46" name="TextBox 45"/>
+          <p:cNvSpPr txBox="1"/>
+          <p:nvPr/>
+        </p:nvSpPr>
+        <p:spPr>
+          <a:xfrm>
+            <a:off x="7699248" y="5111496"/>
+            <a:ext cx="1984248" cy="640080"/>
+          </a:xfrm>
+          <a:prstGeom prst="rect">
+            <a:avLst/>
+          </a:prstGeom>
+          <a:noFill/>
+        </p:spPr>
+        <p:txBody>
+          <a:bodyPr wrap="square" lIns="0" tIns="0" rIns="0" bIns="0">
+            <a:spAutoFit/>
+          </a:bodyPr>
+          <a:lstStyle/>
+          <a:p>
+            <a:pPr algn="ctr"/>
+            <a:r>
+              <a:rPr sz="850" b="0">
+                <a:solidFill>
+                  <a:srgbClr val="475569"/>
+                </a:solidFill>
+                <a:latin typeface="Arial"/>
+              </a:rPr>
+              <a:t>SEC 10-K · ChromaDB · RAG Pipeline</a:t>
+            </a:r>
+          </a:p>
+        </p:txBody>
+      </p:sp>
+      <p:sp>
+        <p:nvSpPr>
+          <p:cNvPr id="47" name="Rounded Rectangle 46"/>
+          <p:cNvSpPr/>
+          <p:nvPr/>
+        </p:nvSpPr>
+        <p:spPr>
+          <a:xfrm>
+            <a:off x="9884664" y="2788920"/>
+            <a:ext cx="2258568" cy="3840480"/>
           </a:xfrm>
           <a:prstGeom prst="roundRect">
             <a:avLst/>
@@ -4408,14 +4937,14 @@
       </p:sp>
       <p:sp>
         <p:nvSpPr>
-          <p:cNvPr id="35" name="Rectangle 34"/>
+          <p:cNvPr id="48" name="Rectangle 47"/>
           <p:cNvSpPr/>
           <p:nvPr/>
         </p:nvSpPr>
         <p:spPr>
           <a:xfrm>
-            <a:off x="10021824" y="3840480"/>
-            <a:ext cx="2258568" cy="50292"/>
+            <a:off x="9884664" y="2788920"/>
+            <a:ext cx="2258568" cy="54864"/>
           </a:xfrm>
           <a:prstGeom prst="rect">
             <a:avLst/>
@@ -4451,14 +4980,14 @@
       </p:sp>
       <p:sp>
         <p:nvSpPr>
-          <p:cNvPr id="36" name="Oval 35"/>
+          <p:cNvPr id="49" name="Oval 48"/>
           <p:cNvSpPr/>
           <p:nvPr/>
         </p:nvSpPr>
         <p:spPr>
           <a:xfrm>
-            <a:off x="10767060" y="4069080"/>
-            <a:ext cx="768096" cy="768096"/>
+            <a:off x="10511028" y="2990088"/>
+            <a:ext cx="1005840" cy="1005840"/>
           </a:xfrm>
           <a:prstGeom prst="ellipse">
             <a:avLst/>
@@ -4494,14 +5023,14 @@
       </p:sp>
       <p:sp>
         <p:nvSpPr>
-          <p:cNvPr id="37" name="TextBox 36"/>
+          <p:cNvPr id="50" name="TextBox 49"/>
           <p:cNvSpPr txBox="1"/>
           <p:nvPr/>
         </p:nvSpPr>
         <p:spPr>
           <a:xfrm>
-            <a:off x="10767060" y="4142232"/>
-            <a:ext cx="768096" cy="457200"/>
+            <a:off x="10511028" y="3099816"/>
+            <a:ext cx="1005840" cy="384048"/>
           </a:xfrm>
           <a:prstGeom prst="rect">
             <a:avLst/>
@@ -4516,7 +5045,7 @@
           <a:p>
             <a:pPr algn="ctr"/>
             <a:r>
-              <a:rPr sz="1400" b="1">
+              <a:rPr sz="1500" b="1">
                 <a:solidFill>
                   <a:srgbClr val="080C18"/>
                 </a:solidFill>
@@ -4529,14 +5058,57 @@
       </p:sp>
       <p:sp>
         <p:nvSpPr>
-          <p:cNvPr id="38" name="TextBox 37"/>
+          <p:cNvPr id="51" name="Rectangle 50"/>
+          <p:cNvSpPr/>
+          <p:nvPr/>
+        </p:nvSpPr>
+        <p:spPr>
+          <a:xfrm>
+            <a:off x="10158984" y="4105656"/>
+            <a:ext cx="1709928" cy="18288"/>
+          </a:xfrm>
+          <a:prstGeom prst="rect">
+            <a:avLst/>
+          </a:prstGeom>
+          <a:solidFill>
+            <a:srgbClr val="1E304A"/>
+          </a:solidFill>
+          <a:ln>
+            <a:noFill/>
+          </a:ln>
+        </p:spPr>
+        <p:style>
+          <a:lnRef idx="1">
+            <a:schemeClr val="accent1"/>
+          </a:lnRef>
+          <a:fillRef idx="3">
+            <a:schemeClr val="accent1"/>
+          </a:fillRef>
+          <a:effectRef idx="2">
+            <a:schemeClr val="accent1"/>
+          </a:effectRef>
+          <a:fontRef idx="minor">
+            <a:schemeClr val="lt1"/>
+          </a:fontRef>
+        </p:style>
+        <p:txBody>
+          <a:bodyPr rtlCol="0" anchor="ctr"/>
+          <a:lstStyle/>
+          <a:p>
+            <a:pPr algn="ctr"/>
+          </a:p>
+        </p:txBody>
+      </p:sp>
+      <p:sp>
+        <p:nvSpPr>
+          <p:cNvPr id="52" name="TextBox 51"/>
           <p:cNvSpPr txBox="1"/>
           <p:nvPr/>
         </p:nvSpPr>
         <p:spPr>
           <a:xfrm>
-            <a:off x="10113264" y="4956048"/>
-            <a:ext cx="2075688" cy="411480"/>
+            <a:off x="9976104" y="4233672"/>
+            <a:ext cx="2075688" cy="384048"/>
           </a:xfrm>
           <a:prstGeom prst="rect">
             <a:avLst/>
@@ -4551,7 +5123,7 @@
           <a:p>
             <a:pPr algn="ctr"/>
             <a:r>
-              <a:rPr sz="1100" b="1">
+              <a:rPr sz="1150" b="1">
                 <a:solidFill>
                   <a:srgbClr val="F8FAFC"/>
                 </a:solidFill>
@@ -4564,14 +5136,14 @@
       </p:sp>
       <p:sp>
         <p:nvSpPr>
-          <p:cNvPr id="39" name="TextBox 38"/>
+          <p:cNvPr id="53" name="TextBox 52"/>
           <p:cNvSpPr txBox="1"/>
           <p:nvPr/>
         </p:nvSpPr>
         <p:spPr>
           <a:xfrm>
-            <a:off x="10113264" y="5349240"/>
-            <a:ext cx="2075688" cy="640080"/>
+            <a:off x="9976104" y="4617720"/>
+            <a:ext cx="2075688" cy="320040"/>
           </a:xfrm>
           <a:prstGeom prst="rect">
             <a:avLst/>
@@ -4593,6 +5165,84 @@
                 <a:latin typeface="Arial"/>
               </a:rPr>
               <a:t>Integration &amp; QA Lead</a:t>
+            </a:r>
+          </a:p>
+        </p:txBody>
+      </p:sp>
+      <p:sp>
+        <p:nvSpPr>
+          <p:cNvPr id="54" name="Rectangle 53"/>
+          <p:cNvSpPr/>
+          <p:nvPr/>
+        </p:nvSpPr>
+        <p:spPr>
+          <a:xfrm>
+            <a:off x="10158984" y="4983480"/>
+            <a:ext cx="1709928" cy="18288"/>
+          </a:xfrm>
+          <a:prstGeom prst="rect">
+            <a:avLst/>
+          </a:prstGeom>
+          <a:solidFill>
+            <a:srgbClr val="1E304A"/>
+          </a:solidFill>
+          <a:ln>
+            <a:noFill/>
+          </a:ln>
+        </p:spPr>
+        <p:style>
+          <a:lnRef idx="1">
+            <a:schemeClr val="accent1"/>
+          </a:lnRef>
+          <a:fillRef idx="3">
+            <a:schemeClr val="accent1"/>
+          </a:fillRef>
+          <a:effectRef idx="2">
+            <a:schemeClr val="accent1"/>
+          </a:effectRef>
+          <a:fontRef idx="minor">
+            <a:schemeClr val="lt1"/>
+          </a:fontRef>
+        </p:style>
+        <p:txBody>
+          <a:bodyPr rtlCol="0" anchor="ctr"/>
+          <a:lstStyle/>
+          <a:p>
+            <a:pPr algn="ctr"/>
+          </a:p>
+        </p:txBody>
+      </p:sp>
+      <p:sp>
+        <p:nvSpPr>
+          <p:cNvPr id="55" name="TextBox 54"/>
+          <p:cNvSpPr txBox="1"/>
+          <p:nvPr/>
+        </p:nvSpPr>
+        <p:spPr>
+          <a:xfrm>
+            <a:off x="10021824" y="5111496"/>
+            <a:ext cx="1984248" cy="640080"/>
+          </a:xfrm>
+          <a:prstGeom prst="rect">
+            <a:avLst/>
+          </a:prstGeom>
+          <a:noFill/>
+        </p:spPr>
+        <p:txBody>
+          <a:bodyPr wrap="square" lIns="0" tIns="0" rIns="0" bIns="0">
+            <a:spAutoFit/>
+          </a:bodyPr>
+          <a:lstStyle/>
+          <a:p>
+            <a:pPr algn="ctr"/>
+            <a:r>
+              <a:rPr sz="850" b="0">
+                <a:solidFill>
+                  <a:srgbClr val="475569"/>
+                </a:solidFill>
+                <a:latin typeface="Arial"/>
+              </a:rPr>
+              <a:t>yfinance · Rate Limits · Test Suite</a:t>
             </a:r>
           </a:p>
         </p:txBody>

</xml_diff>

<commit_message>
fix: simplify cover slide — plain numbered team list, project overview key-value rows, no avatars or cards
</commit_message>
<xml_diff>
--- a/CAPSTONE_PROJECT_PRESENTATION.pptx
+++ b/CAPSTONE_PROJECT_PRESENTATION.pptx
@@ -3157,7 +3157,7 @@
         <p:spPr>
           <a:xfrm>
             <a:off x="0" y="0"/>
-            <a:ext cx="4114800" cy="6858000"/>
+            <a:ext cx="4754880" cy="6858000"/>
           </a:xfrm>
           <a:prstGeom prst="rect">
             <a:avLst/>
@@ -3199,8 +3199,8 @@
         </p:nvSpPr>
         <p:spPr>
           <a:xfrm>
-            <a:off x="4005072" y="0"/>
-            <a:ext cx="109728" cy="6858000"/>
+            <a:off x="4663440" y="0"/>
+            <a:ext cx="91440" cy="6858000"/>
           </a:xfrm>
           <a:prstGeom prst="rect">
             <a:avLst/>
@@ -3242,8 +3242,8 @@
         </p:nvSpPr>
         <p:spPr>
           <a:xfrm>
-            <a:off x="292608" y="292608"/>
-            <a:ext cx="3529584" cy="347472"/>
+            <a:off x="411480" y="347472"/>
+            <a:ext cx="4023360" cy="292608"/>
           </a:xfrm>
           <a:prstGeom prst="rect">
             <a:avLst/>
@@ -3258,13 +3258,13 @@
           <a:p>
             <a:pPr algn="l"/>
             <a:r>
-              <a:rPr sz="900" b="1">
+              <a:rPr sz="850" b="1">
                 <a:solidFill>
                   <a:srgbClr val="1D4ED8"/>
                 </a:solidFill>
                 <a:latin typeface="Calibri"/>
               </a:rPr>
-              <a:t>IIT ROORKEE  &amp;  FUTURENSE</a:t>
+              <a:t>IIT ROORKEE  &amp;  FUTURENSE  ·  JOINT CERTIFICATION</a:t>
             </a:r>
           </a:p>
         </p:txBody>
@@ -3277,8 +3277,8 @@
         </p:nvSpPr>
         <p:spPr>
           <a:xfrm>
-            <a:off x="292608" y="566928"/>
-            <a:ext cx="3529584" cy="292608"/>
+            <a:off x="411480" y="603504"/>
+            <a:ext cx="4023360" cy="274320"/>
           </a:xfrm>
           <a:prstGeom prst="rect">
             <a:avLst/>
@@ -3312,14 +3312,14 @@
         </p:nvSpPr>
         <p:spPr>
           <a:xfrm>
-            <a:off x="292608" y="896112"/>
-            <a:ext cx="3291840" cy="18288"/>
+            <a:off x="411480" y="932688"/>
+            <a:ext cx="3931920" cy="18288"/>
           </a:xfrm>
           <a:prstGeom prst="rect">
             <a:avLst/>
           </a:prstGeom>
           <a:solidFill>
-            <a:srgbClr val="28416E"/>
+            <a:srgbClr val="263C64"/>
           </a:solidFill>
           <a:ln>
             <a:noFill/>
@@ -3355,8 +3355,8 @@
         </p:nvSpPr>
         <p:spPr>
           <a:xfrm>
-            <a:off x="292608" y="1078992"/>
-            <a:ext cx="3529584" cy="1645920"/>
+            <a:off x="411480" y="1078992"/>
+            <a:ext cx="4023360" cy="1828800"/>
           </a:xfrm>
           <a:prstGeom prst="rect">
             <a:avLst/>
@@ -3371,7 +3371,7 @@
           <a:p>
             <a:pPr algn="l"/>
             <a:r>
-              <a:rPr sz="3000" b="1">
+              <a:rPr sz="3200" b="1">
                 <a:solidFill>
                   <a:srgbClr val="FFFFFF"/>
                 </a:solidFill>
@@ -3392,8 +3392,8 @@
         </p:nvSpPr>
         <p:spPr>
           <a:xfrm>
-            <a:off x="292608" y="2834640"/>
-            <a:ext cx="3291840" cy="347472"/>
+            <a:off x="411480" y="3063240"/>
+            <a:ext cx="3931920" cy="347472"/>
           </a:xfrm>
           <a:prstGeom prst="roundRect">
             <a:avLst/>
@@ -3435,8 +3435,8 @@
         </p:nvSpPr>
         <p:spPr>
           <a:xfrm>
-            <a:off x="320040" y="2871216"/>
-            <a:ext cx="3236976" cy="274320"/>
+            <a:off x="438912" y="3090672"/>
+            <a:ext cx="3877056" cy="274320"/>
           </a:xfrm>
           <a:prstGeom prst="rect">
             <a:avLst/>
@@ -3451,13 +3451,13 @@
           <a:p>
             <a:pPr algn="ctr"/>
             <a:r>
-              <a:rPr sz="850" b="1">
+              <a:rPr sz="800" b="1">
                 <a:solidFill>
                   <a:srgbClr val="FFFFFF"/>
                 </a:solidFill>
                 <a:latin typeface="Calibri"/>
               </a:rPr>
-              <a:t>CAPSTONE FINAL DEFENSE  ·  THEME 15</a:t>
+              <a:t>CAPSTONE FINAL DEFENSE  ·  THEME 15  ·  FINANCE DOMAIN</a:t>
             </a:r>
           </a:p>
         </p:txBody>
@@ -3470,8 +3470,8 @@
         </p:nvSpPr>
         <p:spPr>
           <a:xfrm>
-            <a:off x="292608" y="3310128"/>
-            <a:ext cx="3529584" cy="685800"/>
+            <a:off x="411480" y="3529584"/>
+            <a:ext cx="4023360" cy="502920"/>
           </a:xfrm>
           <a:prstGeom prst="rect">
             <a:avLst/>
@@ -3486,39 +3486,36 @@
           <a:p>
             <a:pPr algn="l"/>
             <a:r>
-              <a:rPr sz="1100" b="0">
-                <a:solidFill>
-                  <a:srgbClr val="FFFFFF"/>
-                </a:solidFill>
-                <a:latin typeface="Calibri"/>
-              </a:rPr>
-              <a:t>Autonomous Multi-Agent
-Equity Research Platform</a:t>
-            </a:r>
-          </a:p>
-        </p:txBody>
-      </p:sp>
-      <p:sp>
-        <p:nvSpPr>
-          <p:cNvPr id="12" name="Rounded Rectangle 11"/>
+              <a:rPr sz="1050" b="0">
+                <a:solidFill>
+                  <a:srgbClr val="B4C8E6"/>
+                </a:solidFill>
+                <a:latin typeface="Calibri"/>
+              </a:rPr>
+              <a:t>Autonomous Multi-Agent Equity Research Platform</a:t>
+            </a:r>
+          </a:p>
+        </p:txBody>
+      </p:sp>
+      <p:sp>
+        <p:nvSpPr>
+          <p:cNvPr id="12" name="Rectangle 11"/>
           <p:cNvSpPr/>
           <p:nvPr/>
         </p:nvSpPr>
         <p:spPr>
           <a:xfrm>
-            <a:off x="4407408" y="201168"/>
-            <a:ext cx="1499616" cy="6455664"/>
-          </a:xfrm>
-          <a:prstGeom prst="roundRect">
+            <a:off x="411480" y="4160520"/>
+            <a:ext cx="3931920" cy="18288"/>
+          </a:xfrm>
+          <a:prstGeom prst="rect">
             <a:avLst/>
           </a:prstGeom>
           <a:solidFill>
-            <a:srgbClr val="F0F5FC"/>
+            <a:srgbClr val="263C64"/>
           </a:solidFill>
-          <a:ln w="9525">
-            <a:solidFill>
-              <a:srgbClr val="CBD5E1"/>
-            </a:solidFill>
+          <a:ln>
+            <a:noFill/>
           </a:ln>
         </p:spPr>
         <p:style>
@@ -3545,14 +3542,609 @@
       </p:sp>
       <p:sp>
         <p:nvSpPr>
-          <p:cNvPr id="13" name="Rectangle 12"/>
+          <p:cNvPr id="13" name="TextBox 12"/>
+          <p:cNvSpPr txBox="1"/>
+          <p:nvPr/>
+        </p:nvSpPr>
+        <p:spPr>
+          <a:xfrm>
+            <a:off x="411480" y="4251960"/>
+            <a:ext cx="4023360" cy="274320"/>
+          </a:xfrm>
+          <a:prstGeom prst="rect">
+            <a:avLst/>
+          </a:prstGeom>
+          <a:noFill/>
+        </p:spPr>
+        <p:txBody>
+          <a:bodyPr wrap="square" lIns="0" tIns="0" rIns="0" bIns="0">
+            <a:spAutoFit/>
+          </a:bodyPr>
+          <a:lstStyle/>
+          <a:p>
+            <a:pPr algn="l"/>
+            <a:r>
+              <a:rPr sz="800" b="1">
+                <a:solidFill>
+                  <a:srgbClr val="1D4ED8"/>
+                </a:solidFill>
+                <a:latin typeface="Calibri"/>
+              </a:rPr>
+              <a:t>PROJECT TEAM</a:t>
+            </a:r>
+          </a:p>
+        </p:txBody>
+      </p:sp>
+      <p:sp>
+        <p:nvSpPr>
+          <p:cNvPr id="14" name="TextBox 13"/>
+          <p:cNvSpPr txBox="1"/>
+          <p:nvPr/>
+        </p:nvSpPr>
+        <p:spPr>
+          <a:xfrm>
+            <a:off x="411480" y="4590288"/>
+            <a:ext cx="292608" cy="347472"/>
+          </a:xfrm>
+          <a:prstGeom prst="rect">
+            <a:avLst/>
+          </a:prstGeom>
+          <a:noFill/>
+        </p:spPr>
+        <p:txBody>
+          <a:bodyPr wrap="square" lIns="0" tIns="0" rIns="0" bIns="0">
+            <a:spAutoFit/>
+          </a:bodyPr>
+          <a:lstStyle/>
+          <a:p>
+            <a:pPr algn="l"/>
+            <a:r>
+              <a:rPr sz="950" b="1">
+                <a:solidFill>
+                  <a:srgbClr val="1D4ED8"/>
+                </a:solidFill>
+                <a:latin typeface="Calibri"/>
+              </a:rPr>
+              <a:t>1.</a:t>
+            </a:r>
+          </a:p>
+        </p:txBody>
+      </p:sp>
+      <p:sp>
+        <p:nvSpPr>
+          <p:cNvPr id="15" name="TextBox 14"/>
+          <p:cNvSpPr txBox="1"/>
+          <p:nvPr/>
+        </p:nvSpPr>
+        <p:spPr>
+          <a:xfrm>
+            <a:off x="713232" y="4590288"/>
+            <a:ext cx="1371600" cy="347472"/>
+          </a:xfrm>
+          <a:prstGeom prst="rect">
+            <a:avLst/>
+          </a:prstGeom>
+          <a:noFill/>
+        </p:spPr>
+        <p:txBody>
+          <a:bodyPr wrap="square" lIns="0" tIns="0" rIns="0" bIns="0">
+            <a:spAutoFit/>
+          </a:bodyPr>
+          <a:lstStyle/>
+          <a:p>
+            <a:pPr algn="l"/>
+            <a:r>
+              <a:rPr sz="950" b="1">
+                <a:solidFill>
+                  <a:srgbClr val="FFFFFF"/>
+                </a:solidFill>
+                <a:latin typeface="Calibri"/>
+              </a:rPr>
+              <a:t>Ganesh Swami</a:t>
+            </a:r>
+          </a:p>
+        </p:txBody>
+      </p:sp>
+      <p:sp>
+        <p:nvSpPr>
+          <p:cNvPr id="16" name="TextBox 15"/>
+          <p:cNvSpPr txBox="1"/>
+          <p:nvPr/>
+        </p:nvSpPr>
+        <p:spPr>
+          <a:xfrm>
+            <a:off x="2084831" y="4590288"/>
+            <a:ext cx="2395728" cy="347472"/>
+          </a:xfrm>
+          <a:prstGeom prst="rect">
+            <a:avLst/>
+          </a:prstGeom>
+          <a:noFill/>
+        </p:spPr>
+        <p:txBody>
+          <a:bodyPr wrap="square" lIns="0" tIns="0" rIns="0" bIns="0">
+            <a:spAutoFit/>
+          </a:bodyPr>
+          <a:lstStyle/>
+          <a:p>
+            <a:pPr algn="l"/>
+            <a:r>
+              <a:rPr sz="850" b="0">
+                <a:solidFill>
+                  <a:srgbClr val="A0B9D7"/>
+                </a:solidFill>
+                <a:latin typeface="Calibri"/>
+              </a:rPr>
+              <a:t>Backend Architecture &amp; Cloud DevOps Lead</a:t>
+            </a:r>
+          </a:p>
+        </p:txBody>
+      </p:sp>
+      <p:sp>
+        <p:nvSpPr>
+          <p:cNvPr id="17" name="TextBox 16"/>
+          <p:cNvSpPr txBox="1"/>
+          <p:nvPr/>
+        </p:nvSpPr>
+        <p:spPr>
+          <a:xfrm>
+            <a:off x="411480" y="4992624"/>
+            <a:ext cx="292608" cy="347472"/>
+          </a:xfrm>
+          <a:prstGeom prst="rect">
+            <a:avLst/>
+          </a:prstGeom>
+          <a:noFill/>
+        </p:spPr>
+        <p:txBody>
+          <a:bodyPr wrap="square" lIns="0" tIns="0" rIns="0" bIns="0">
+            <a:spAutoFit/>
+          </a:bodyPr>
+          <a:lstStyle/>
+          <a:p>
+            <a:pPr algn="l"/>
+            <a:r>
+              <a:rPr sz="950" b="1">
+                <a:solidFill>
+                  <a:srgbClr val="1D4ED8"/>
+                </a:solidFill>
+                <a:latin typeface="Calibri"/>
+              </a:rPr>
+              <a:t>2.</a:t>
+            </a:r>
+          </a:p>
+        </p:txBody>
+      </p:sp>
+      <p:sp>
+        <p:nvSpPr>
+          <p:cNvPr id="18" name="TextBox 17"/>
+          <p:cNvSpPr txBox="1"/>
+          <p:nvPr/>
+        </p:nvSpPr>
+        <p:spPr>
+          <a:xfrm>
+            <a:off x="713232" y="4992624"/>
+            <a:ext cx="1371600" cy="347472"/>
+          </a:xfrm>
+          <a:prstGeom prst="rect">
+            <a:avLst/>
+          </a:prstGeom>
+          <a:noFill/>
+        </p:spPr>
+        <p:txBody>
+          <a:bodyPr wrap="square" lIns="0" tIns="0" rIns="0" bIns="0">
+            <a:spAutoFit/>
+          </a:bodyPr>
+          <a:lstStyle/>
+          <a:p>
+            <a:pPr algn="l"/>
+            <a:r>
+              <a:rPr sz="950" b="1">
+                <a:solidFill>
+                  <a:srgbClr val="FFFFFF"/>
+                </a:solidFill>
+                <a:latin typeface="Calibri"/>
+              </a:rPr>
+              <a:t>Shradha Gaikwad</a:t>
+            </a:r>
+          </a:p>
+        </p:txBody>
+      </p:sp>
+      <p:sp>
+        <p:nvSpPr>
+          <p:cNvPr id="19" name="TextBox 18"/>
+          <p:cNvSpPr txBox="1"/>
+          <p:nvPr/>
+        </p:nvSpPr>
+        <p:spPr>
+          <a:xfrm>
+            <a:off x="2084831" y="4992624"/>
+            <a:ext cx="2395728" cy="347472"/>
+          </a:xfrm>
+          <a:prstGeom prst="rect">
+            <a:avLst/>
+          </a:prstGeom>
+          <a:noFill/>
+        </p:spPr>
+        <p:txBody>
+          <a:bodyPr wrap="square" lIns="0" tIns="0" rIns="0" bIns="0">
+            <a:spAutoFit/>
+          </a:bodyPr>
+          <a:lstStyle/>
+          <a:p>
+            <a:pPr algn="l"/>
+            <a:r>
+              <a:rPr sz="850" b="0">
+                <a:solidFill>
+                  <a:srgbClr val="A0B9D7"/>
+                </a:solidFill>
+                <a:latin typeface="Calibri"/>
+              </a:rPr>
+              <a:t>Financial Agent Intelligence &amp; Modeling Lead</a:t>
+            </a:r>
+          </a:p>
+        </p:txBody>
+      </p:sp>
+      <p:sp>
+        <p:nvSpPr>
+          <p:cNvPr id="20" name="TextBox 19"/>
+          <p:cNvSpPr txBox="1"/>
+          <p:nvPr/>
+        </p:nvSpPr>
+        <p:spPr>
+          <a:xfrm>
+            <a:off x="411480" y="5394960"/>
+            <a:ext cx="292608" cy="347472"/>
+          </a:xfrm>
+          <a:prstGeom prst="rect">
+            <a:avLst/>
+          </a:prstGeom>
+          <a:noFill/>
+        </p:spPr>
+        <p:txBody>
+          <a:bodyPr wrap="square" lIns="0" tIns="0" rIns="0" bIns="0">
+            <a:spAutoFit/>
+          </a:bodyPr>
+          <a:lstStyle/>
+          <a:p>
+            <a:pPr algn="l"/>
+            <a:r>
+              <a:rPr sz="950" b="1">
+                <a:solidFill>
+                  <a:srgbClr val="1D4ED8"/>
+                </a:solidFill>
+                <a:latin typeface="Calibri"/>
+              </a:rPr>
+              <a:t>3.</a:t>
+            </a:r>
+          </a:p>
+        </p:txBody>
+      </p:sp>
+      <p:sp>
+        <p:nvSpPr>
+          <p:cNvPr id="21" name="TextBox 20"/>
+          <p:cNvSpPr txBox="1"/>
+          <p:nvPr/>
+        </p:nvSpPr>
+        <p:spPr>
+          <a:xfrm>
+            <a:off x="713232" y="5394960"/>
+            <a:ext cx="1371600" cy="347472"/>
+          </a:xfrm>
+          <a:prstGeom prst="rect">
+            <a:avLst/>
+          </a:prstGeom>
+          <a:noFill/>
+        </p:spPr>
+        <p:txBody>
+          <a:bodyPr wrap="square" lIns="0" tIns="0" rIns="0" bIns="0">
+            <a:spAutoFit/>
+          </a:bodyPr>
+          <a:lstStyle/>
+          <a:p>
+            <a:pPr algn="l"/>
+            <a:r>
+              <a:rPr sz="950" b="1">
+                <a:solidFill>
+                  <a:srgbClr val="FFFFFF"/>
+                </a:solidFill>
+                <a:latin typeface="Calibri"/>
+              </a:rPr>
+              <a:t>Sagar Trimukhe</a:t>
+            </a:r>
+          </a:p>
+        </p:txBody>
+      </p:sp>
+      <p:sp>
+        <p:nvSpPr>
+          <p:cNvPr id="22" name="TextBox 21"/>
+          <p:cNvSpPr txBox="1"/>
+          <p:nvPr/>
+        </p:nvSpPr>
+        <p:spPr>
+          <a:xfrm>
+            <a:off x="2084831" y="5394960"/>
+            <a:ext cx="2395728" cy="347472"/>
+          </a:xfrm>
+          <a:prstGeom prst="rect">
+            <a:avLst/>
+          </a:prstGeom>
+          <a:noFill/>
+        </p:spPr>
+        <p:txBody>
+          <a:bodyPr wrap="square" lIns="0" tIns="0" rIns="0" bIns="0">
+            <a:spAutoFit/>
+          </a:bodyPr>
+          <a:lstStyle/>
+          <a:p>
+            <a:pPr algn="l"/>
+            <a:r>
+              <a:rPr sz="850" b="0">
+                <a:solidFill>
+                  <a:srgbClr val="A0B9D7"/>
+                </a:solidFill>
+                <a:latin typeface="Calibri"/>
+              </a:rPr>
+              <a:t>Frontend UI &amp; HITL Integration Lead</a:t>
+            </a:r>
+          </a:p>
+        </p:txBody>
+      </p:sp>
+      <p:sp>
+        <p:nvSpPr>
+          <p:cNvPr id="23" name="TextBox 22"/>
+          <p:cNvSpPr txBox="1"/>
+          <p:nvPr/>
+        </p:nvSpPr>
+        <p:spPr>
+          <a:xfrm>
+            <a:off x="411480" y="5797296"/>
+            <a:ext cx="292608" cy="347472"/>
+          </a:xfrm>
+          <a:prstGeom prst="rect">
+            <a:avLst/>
+          </a:prstGeom>
+          <a:noFill/>
+        </p:spPr>
+        <p:txBody>
+          <a:bodyPr wrap="square" lIns="0" tIns="0" rIns="0" bIns="0">
+            <a:spAutoFit/>
+          </a:bodyPr>
+          <a:lstStyle/>
+          <a:p>
+            <a:pPr algn="l"/>
+            <a:r>
+              <a:rPr sz="950" b="1">
+                <a:solidFill>
+                  <a:srgbClr val="1D4ED8"/>
+                </a:solidFill>
+                <a:latin typeface="Calibri"/>
+              </a:rPr>
+              <a:t>4.</a:t>
+            </a:r>
+          </a:p>
+        </p:txBody>
+      </p:sp>
+      <p:sp>
+        <p:nvSpPr>
+          <p:cNvPr id="24" name="TextBox 23"/>
+          <p:cNvSpPr txBox="1"/>
+          <p:nvPr/>
+        </p:nvSpPr>
+        <p:spPr>
+          <a:xfrm>
+            <a:off x="713232" y="5797296"/>
+            <a:ext cx="1371600" cy="347472"/>
+          </a:xfrm>
+          <a:prstGeom prst="rect">
+            <a:avLst/>
+          </a:prstGeom>
+          <a:noFill/>
+        </p:spPr>
+        <p:txBody>
+          <a:bodyPr wrap="square" lIns="0" tIns="0" rIns="0" bIns="0">
+            <a:spAutoFit/>
+          </a:bodyPr>
+          <a:lstStyle/>
+          <a:p>
+            <a:pPr algn="l"/>
+            <a:r>
+              <a:rPr sz="950" b="1">
+                <a:solidFill>
+                  <a:srgbClr val="FFFFFF"/>
+                </a:solidFill>
+                <a:latin typeface="Calibri"/>
+              </a:rPr>
+              <a:t>Nilanjan Das</a:t>
+            </a:r>
+          </a:p>
+        </p:txBody>
+      </p:sp>
+      <p:sp>
+        <p:nvSpPr>
+          <p:cNvPr id="25" name="TextBox 24"/>
+          <p:cNvSpPr txBox="1"/>
+          <p:nvPr/>
+        </p:nvSpPr>
+        <p:spPr>
+          <a:xfrm>
+            <a:off x="2084831" y="5797296"/>
+            <a:ext cx="2395728" cy="347472"/>
+          </a:xfrm>
+          <a:prstGeom prst="rect">
+            <a:avLst/>
+          </a:prstGeom>
+          <a:noFill/>
+        </p:spPr>
+        <p:txBody>
+          <a:bodyPr wrap="square" lIns="0" tIns="0" rIns="0" bIns="0">
+            <a:spAutoFit/>
+          </a:bodyPr>
+          <a:lstStyle/>
+          <a:p>
+            <a:pPr algn="l"/>
+            <a:r>
+              <a:rPr sz="850" b="0">
+                <a:solidFill>
+                  <a:srgbClr val="A0B9D7"/>
+                </a:solidFill>
+                <a:latin typeface="Calibri"/>
+              </a:rPr>
+              <a:t>Data Engineering &amp; SEC RAG Pipeline Lead</a:t>
+            </a:r>
+          </a:p>
+        </p:txBody>
+      </p:sp>
+      <p:sp>
+        <p:nvSpPr>
+          <p:cNvPr id="26" name="TextBox 25"/>
+          <p:cNvSpPr txBox="1"/>
+          <p:nvPr/>
+        </p:nvSpPr>
+        <p:spPr>
+          <a:xfrm>
+            <a:off x="411480" y="6199632"/>
+            <a:ext cx="292608" cy="347472"/>
+          </a:xfrm>
+          <a:prstGeom prst="rect">
+            <a:avLst/>
+          </a:prstGeom>
+          <a:noFill/>
+        </p:spPr>
+        <p:txBody>
+          <a:bodyPr wrap="square" lIns="0" tIns="0" rIns="0" bIns="0">
+            <a:spAutoFit/>
+          </a:bodyPr>
+          <a:lstStyle/>
+          <a:p>
+            <a:pPr algn="l"/>
+            <a:r>
+              <a:rPr sz="950" b="1">
+                <a:solidFill>
+                  <a:srgbClr val="1D4ED8"/>
+                </a:solidFill>
+                <a:latin typeface="Calibri"/>
+              </a:rPr>
+              <a:t>5.</a:t>
+            </a:r>
+          </a:p>
+        </p:txBody>
+      </p:sp>
+      <p:sp>
+        <p:nvSpPr>
+          <p:cNvPr id="27" name="TextBox 26"/>
+          <p:cNvSpPr txBox="1"/>
+          <p:nvPr/>
+        </p:nvSpPr>
+        <p:spPr>
+          <a:xfrm>
+            <a:off x="713232" y="6199632"/>
+            <a:ext cx="1371600" cy="347472"/>
+          </a:xfrm>
+          <a:prstGeom prst="rect">
+            <a:avLst/>
+          </a:prstGeom>
+          <a:noFill/>
+        </p:spPr>
+        <p:txBody>
+          <a:bodyPr wrap="square" lIns="0" tIns="0" rIns="0" bIns="0">
+            <a:spAutoFit/>
+          </a:bodyPr>
+          <a:lstStyle/>
+          <a:p>
+            <a:pPr algn="l"/>
+            <a:r>
+              <a:rPr sz="950" b="1">
+                <a:solidFill>
+                  <a:srgbClr val="FFFFFF"/>
+                </a:solidFill>
+                <a:latin typeface="Calibri"/>
+              </a:rPr>
+              <a:t>Nikhil Gaikwad</a:t>
+            </a:r>
+          </a:p>
+        </p:txBody>
+      </p:sp>
+      <p:sp>
+        <p:nvSpPr>
+          <p:cNvPr id="28" name="TextBox 27"/>
+          <p:cNvSpPr txBox="1"/>
+          <p:nvPr/>
+        </p:nvSpPr>
+        <p:spPr>
+          <a:xfrm>
+            <a:off x="2084831" y="6199632"/>
+            <a:ext cx="2395728" cy="347472"/>
+          </a:xfrm>
+          <a:prstGeom prst="rect">
+            <a:avLst/>
+          </a:prstGeom>
+          <a:noFill/>
+        </p:spPr>
+        <p:txBody>
+          <a:bodyPr wrap="square" lIns="0" tIns="0" rIns="0" bIns="0">
+            <a:spAutoFit/>
+          </a:bodyPr>
+          <a:lstStyle/>
+          <a:p>
+            <a:pPr algn="l"/>
+            <a:r>
+              <a:rPr sz="850" b="0">
+                <a:solidFill>
+                  <a:srgbClr val="A0B9D7"/>
+                </a:solidFill>
+                <a:latin typeface="Calibri"/>
+              </a:rPr>
+              <a:t>Full-Stack Integration &amp; QA Lead</a:t>
+            </a:r>
+          </a:p>
+        </p:txBody>
+      </p:sp>
+      <p:sp>
+        <p:nvSpPr>
+          <p:cNvPr id="29" name="TextBox 28"/>
+          <p:cNvSpPr txBox="1"/>
+          <p:nvPr/>
+        </p:nvSpPr>
+        <p:spPr>
+          <a:xfrm>
+            <a:off x="5029200" y="347472"/>
+            <a:ext cx="6858000" cy="320040"/>
+          </a:xfrm>
+          <a:prstGeom prst="rect">
+            <a:avLst/>
+          </a:prstGeom>
+          <a:noFill/>
+        </p:spPr>
+        <p:txBody>
+          <a:bodyPr wrap="square" lIns="0" tIns="0" rIns="0" bIns="0">
+            <a:spAutoFit/>
+          </a:bodyPr>
+          <a:lstStyle/>
+          <a:p>
+            <a:pPr algn="l"/>
+            <a:r>
+              <a:rPr sz="900" b="1">
+                <a:solidFill>
+                  <a:srgbClr val="64748B"/>
+                </a:solidFill>
+                <a:latin typeface="Calibri"/>
+              </a:rPr>
+              <a:t>PROJECT OVERVIEW</a:t>
+            </a:r>
+          </a:p>
+        </p:txBody>
+      </p:sp>
+      <p:sp>
+        <p:nvSpPr>
+          <p:cNvPr id="30" name="Rectangle 29"/>
           <p:cNvSpPr/>
           <p:nvPr/>
         </p:nvSpPr>
         <p:spPr>
           <a:xfrm>
-            <a:off x="4407408" y="201168"/>
-            <a:ext cx="1499616" cy="54864"/>
+            <a:off x="5029200" y="694944"/>
+            <a:ext cx="6858000" cy="36576"/>
           </a:xfrm>
           <a:prstGeom prst="rect">
             <a:avLst/>
@@ -3588,23 +4180,25 @@
       </p:sp>
       <p:sp>
         <p:nvSpPr>
-          <p:cNvPr id="14" name="Oval 13"/>
+          <p:cNvPr id="31" name="Rounded Rectangle 30"/>
           <p:cNvSpPr/>
           <p:nvPr/>
         </p:nvSpPr>
         <p:spPr>
           <a:xfrm>
-            <a:off x="4700016" y="384048"/>
-            <a:ext cx="914400" cy="914400"/>
-          </a:xfrm>
-          <a:prstGeom prst="ellipse">
+            <a:off x="5029200" y="914400"/>
+            <a:ext cx="2560320" cy="292608"/>
+          </a:xfrm>
+          <a:prstGeom prst="roundRect">
             <a:avLst/>
           </a:prstGeom>
           <a:solidFill>
-            <a:srgbClr val="1D4ED8"/>
+            <a:srgbClr val="F0F5FC"/>
           </a:solidFill>
-          <a:ln>
-            <a:noFill/>
+          <a:ln w="6350">
+            <a:solidFill>
+              <a:srgbClr val="CBD5E1"/>
+            </a:solidFill>
           </a:ln>
         </p:spPr>
         <p:style>
@@ -3631,14 +4225,14 @@
       </p:sp>
       <p:sp>
         <p:nvSpPr>
-          <p:cNvPr id="15" name="TextBox 14"/>
+          <p:cNvPr id="32" name="TextBox 31"/>
           <p:cNvSpPr txBox="1"/>
           <p:nvPr/>
         </p:nvSpPr>
         <p:spPr>
           <a:xfrm>
-            <a:off x="4700016" y="475488"/>
-            <a:ext cx="914400" cy="347472"/>
+            <a:off x="5074920" y="950976"/>
+            <a:ext cx="2468880" cy="256032"/>
           </a:xfrm>
           <a:prstGeom prst="rect">
             <a:avLst/>
@@ -3651,29 +4245,29 @@
           </a:bodyPr>
           <a:lstStyle/>
           <a:p>
-            <a:pPr algn="ctr"/>
-            <a:r>
-              <a:rPr sz="1400" b="1">
-                <a:solidFill>
-                  <a:srgbClr val="FFFFFF"/>
-                </a:solidFill>
-                <a:latin typeface="Calibri"/>
-              </a:rPr>
-              <a:t>GS</a:t>
-            </a:r>
-          </a:p>
-        </p:txBody>
-      </p:sp>
-      <p:sp>
-        <p:nvSpPr>
-          <p:cNvPr id="16" name="TextBox 15"/>
+            <a:pPr algn="l"/>
+            <a:r>
+              <a:rPr sz="850" b="1">
+                <a:solidFill>
+                  <a:srgbClr val="1D4ED8"/>
+                </a:solidFill>
+                <a:latin typeface="Calibri"/>
+              </a:rPr>
+              <a:t>Project Title</a:t>
+            </a:r>
+          </a:p>
+        </p:txBody>
+      </p:sp>
+      <p:sp>
+        <p:nvSpPr>
+          <p:cNvPr id="33" name="TextBox 32"/>
           <p:cNvSpPr txBox="1"/>
           <p:nvPr/>
         </p:nvSpPr>
         <p:spPr>
           <a:xfrm>
-            <a:off x="4480560" y="1426464"/>
-            <a:ext cx="1353312" cy="475488"/>
+            <a:off x="7699248" y="950976"/>
+            <a:ext cx="4206240" cy="256032"/>
           </a:xfrm>
           <a:prstGeom prst="rect">
             <a:avLst/>
@@ -3686,38 +4280,40 @@
           </a:bodyPr>
           <a:lstStyle/>
           <a:p>
-            <a:pPr algn="ctr"/>
-            <a:r>
-              <a:rPr sz="950" b="1">
-                <a:solidFill>
-                  <a:srgbClr val="0F2040"/>
-                </a:solidFill>
-                <a:latin typeface="Calibri"/>
-              </a:rPr>
-              <a:t>Ganesh Swami</a:t>
-            </a:r>
-          </a:p>
-        </p:txBody>
-      </p:sp>
-      <p:sp>
-        <p:nvSpPr>
-          <p:cNvPr id="17" name="Rectangle 16"/>
+            <a:pPr algn="l"/>
+            <a:r>
+              <a:rPr sz="950" b="0">
+                <a:solidFill>
+                  <a:srgbClr val="334155"/>
+                </a:solidFill>
+                <a:latin typeface="Calibri"/>
+              </a:rPr>
+              <a:t>AI Investment Research Assistant</a:t>
+            </a:r>
+          </a:p>
+        </p:txBody>
+      </p:sp>
+      <p:sp>
+        <p:nvSpPr>
+          <p:cNvPr id="34" name="Rounded Rectangle 33"/>
           <p:cNvSpPr/>
           <p:nvPr/>
         </p:nvSpPr>
         <p:spPr>
           <a:xfrm>
-            <a:off x="4590288" y="1938528"/>
-            <a:ext cx="1133856" cy="13716"/>
-          </a:xfrm>
-          <a:prstGeom prst="rect">
+            <a:off x="5029200" y="1481328"/>
+            <a:ext cx="2560320" cy="292608"/>
+          </a:xfrm>
+          <a:prstGeom prst="roundRect">
             <a:avLst/>
           </a:prstGeom>
           <a:solidFill>
-            <a:srgbClr val="CBD5E1"/>
+            <a:srgbClr val="F0F5FC"/>
           </a:solidFill>
-          <a:ln>
-            <a:noFill/>
+          <a:ln w="6350">
+            <a:solidFill>
+              <a:srgbClr val="CBD5E1"/>
+            </a:solidFill>
           </a:ln>
         </p:spPr>
         <p:style>
@@ -3744,14 +4340,14 @@
       </p:sp>
       <p:sp>
         <p:nvSpPr>
-          <p:cNvPr id="18" name="TextBox 17"/>
+          <p:cNvPr id="35" name="TextBox 34"/>
           <p:cNvSpPr txBox="1"/>
           <p:nvPr/>
         </p:nvSpPr>
         <p:spPr>
           <a:xfrm>
-            <a:off x="4480560" y="2029968"/>
-            <a:ext cx="1353312" cy="365760"/>
+            <a:off x="5074920" y="1517904"/>
+            <a:ext cx="2468880" cy="256032"/>
           </a:xfrm>
           <a:prstGeom prst="rect">
             <a:avLst/>
@@ -3764,38 +4360,75 @@
           </a:bodyPr>
           <a:lstStyle/>
           <a:p>
-            <a:pPr algn="ctr"/>
-            <a:r>
-              <a:rPr sz="800" b="1">
+            <a:pPr algn="l"/>
+            <a:r>
+              <a:rPr sz="850" b="1">
                 <a:solidFill>
                   <a:srgbClr val="1D4ED8"/>
                 </a:solidFill>
                 <a:latin typeface="Calibri"/>
               </a:rPr>
-              <a:t>Backend &amp; Cloud Lead</a:t>
-            </a:r>
-          </a:p>
-        </p:txBody>
-      </p:sp>
-      <p:sp>
-        <p:nvSpPr>
-          <p:cNvPr id="19" name="Rectangle 18"/>
+              <a:t>Domain</a:t>
+            </a:r>
+          </a:p>
+        </p:txBody>
+      </p:sp>
+      <p:sp>
+        <p:nvSpPr>
+          <p:cNvPr id="36" name="TextBox 35"/>
+          <p:cNvSpPr txBox="1"/>
+          <p:nvPr/>
+        </p:nvSpPr>
+        <p:spPr>
+          <a:xfrm>
+            <a:off x="7699248" y="1517904"/>
+            <a:ext cx="4206240" cy="256032"/>
+          </a:xfrm>
+          <a:prstGeom prst="rect">
+            <a:avLst/>
+          </a:prstGeom>
+          <a:noFill/>
+        </p:spPr>
+        <p:txBody>
+          <a:bodyPr wrap="square" lIns="0" tIns="0" rIns="0" bIns="0">
+            <a:spAutoFit/>
+          </a:bodyPr>
+          <a:lstStyle/>
+          <a:p>
+            <a:pPr algn="l"/>
+            <a:r>
+              <a:rPr sz="950" b="0">
+                <a:solidFill>
+                  <a:srgbClr val="334155"/>
+                </a:solidFill>
+                <a:latin typeface="Calibri"/>
+              </a:rPr>
+              <a:t>Finance — Autonomous Equity Research</a:t>
+            </a:r>
+          </a:p>
+        </p:txBody>
+      </p:sp>
+      <p:sp>
+        <p:nvSpPr>
+          <p:cNvPr id="37" name="Rounded Rectangle 36"/>
           <p:cNvSpPr/>
           <p:nvPr/>
         </p:nvSpPr>
         <p:spPr>
           <a:xfrm>
-            <a:off x="4590288" y="2450592"/>
-            <a:ext cx="1133856" cy="13716"/>
-          </a:xfrm>
-          <a:prstGeom prst="rect">
+            <a:off x="5029200" y="2048256"/>
+            <a:ext cx="2560320" cy="292608"/>
+          </a:xfrm>
+          <a:prstGeom prst="roundRect">
             <a:avLst/>
           </a:prstGeom>
           <a:solidFill>
-            <a:srgbClr val="CBD5E1"/>
+            <a:srgbClr val="F0F5FC"/>
           </a:solidFill>
-          <a:ln>
-            <a:noFill/>
+          <a:ln w="6350">
+            <a:solidFill>
+              <a:srgbClr val="CBD5E1"/>
+            </a:solidFill>
           </a:ln>
         </p:spPr>
         <p:style>
@@ -3822,14 +4455,14 @@
       </p:sp>
       <p:sp>
         <p:nvSpPr>
-          <p:cNvPr id="20" name="TextBox 19"/>
+          <p:cNvPr id="38" name="TextBox 37"/>
           <p:cNvSpPr txBox="1"/>
           <p:nvPr/>
         </p:nvSpPr>
         <p:spPr>
           <a:xfrm>
-            <a:off x="4498848" y="2560320"/>
-            <a:ext cx="1316736" cy="1280160"/>
+            <a:off x="5074920" y="2084832"/>
+            <a:ext cx="2468880" cy="256032"/>
           </a:xfrm>
           <a:prstGeom prst="rect">
             <a:avLst/>
@@ -3842,31 +4475,64 @@
           </a:bodyPr>
           <a:lstStyle/>
           <a:p>
-            <a:pPr algn="ctr"/>
-            <a:r>
-              <a:rPr sz="800" b="0">
-                <a:solidFill>
-                  <a:srgbClr val="64748B"/>
-                </a:solidFill>
-                <a:latin typeface="Calibri"/>
-              </a:rPr>
-              <a:t>LangGraph DAG
-AWS EC2
-Docker Compose</a:t>
-            </a:r>
-          </a:p>
-        </p:txBody>
-      </p:sp>
-      <p:sp>
-        <p:nvSpPr>
-          <p:cNvPr id="21" name="Rounded Rectangle 20"/>
+            <a:pPr algn="l"/>
+            <a:r>
+              <a:rPr sz="850" b="1">
+                <a:solidFill>
+                  <a:srgbClr val="1D4ED8"/>
+                </a:solidFill>
+                <a:latin typeface="Calibri"/>
+              </a:rPr>
+              <a:t>Orchestration</a:t>
+            </a:r>
+          </a:p>
+        </p:txBody>
+      </p:sp>
+      <p:sp>
+        <p:nvSpPr>
+          <p:cNvPr id="39" name="TextBox 38"/>
+          <p:cNvSpPr txBox="1"/>
+          <p:nvPr/>
+        </p:nvSpPr>
+        <p:spPr>
+          <a:xfrm>
+            <a:off x="7699248" y="2084832"/>
+            <a:ext cx="4206240" cy="256032"/>
+          </a:xfrm>
+          <a:prstGeom prst="rect">
+            <a:avLst/>
+          </a:prstGeom>
+          <a:noFill/>
+        </p:spPr>
+        <p:txBody>
+          <a:bodyPr wrap="square" lIns="0" tIns="0" rIns="0" bIns="0">
+            <a:spAutoFit/>
+          </a:bodyPr>
+          <a:lstStyle/>
+          <a:p>
+            <a:pPr algn="l"/>
+            <a:r>
+              <a:rPr sz="950" b="0">
+                <a:solidFill>
+                  <a:srgbClr val="334155"/>
+                </a:solidFill>
+                <a:latin typeface="Calibri"/>
+              </a:rPr>
+              <a:t>LangGraph Stateful DAG (Multi-Agent)</a:t>
+            </a:r>
+          </a:p>
+        </p:txBody>
+      </p:sp>
+      <p:sp>
+        <p:nvSpPr>
+          <p:cNvPr id="40" name="Rounded Rectangle 39"/>
           <p:cNvSpPr/>
           <p:nvPr/>
         </p:nvSpPr>
         <p:spPr>
           <a:xfrm>
-            <a:off x="5961888" y="201168"/>
-            <a:ext cx="1499616" cy="6455664"/>
+            <a:off x="5029200" y="2615184"/>
+            <a:ext cx="2560320" cy="292608"/>
           </a:xfrm>
           <a:prstGeom prst="roundRect">
             <a:avLst/>
@@ -3874,7 +4540,7 @@
           <a:solidFill>
             <a:srgbClr val="F0F5FC"/>
           </a:solidFill>
-          <a:ln w="9525">
+          <a:ln w="6350">
             <a:solidFill>
               <a:srgbClr val="CBD5E1"/>
             </a:solidFill>
@@ -3904,23 +4570,95 @@
       </p:sp>
       <p:sp>
         <p:nvSpPr>
-          <p:cNvPr id="22" name="Rectangle 21"/>
+          <p:cNvPr id="41" name="TextBox 40"/>
+          <p:cNvSpPr txBox="1"/>
+          <p:nvPr/>
+        </p:nvSpPr>
+        <p:spPr>
+          <a:xfrm>
+            <a:off x="5074920" y="2651760"/>
+            <a:ext cx="2468880" cy="256032"/>
+          </a:xfrm>
+          <a:prstGeom prst="rect">
+            <a:avLst/>
+          </a:prstGeom>
+          <a:noFill/>
+        </p:spPr>
+        <p:txBody>
+          <a:bodyPr wrap="square" lIns="0" tIns="0" rIns="0" bIns="0">
+            <a:spAutoFit/>
+          </a:bodyPr>
+          <a:lstStyle/>
+          <a:p>
+            <a:pPr algn="l"/>
+            <a:r>
+              <a:rPr sz="850" b="1">
+                <a:solidFill>
+                  <a:srgbClr val="1D4ED8"/>
+                </a:solidFill>
+                <a:latin typeface="Calibri"/>
+              </a:rPr>
+              <a:t>LLM Inference</a:t>
+            </a:r>
+          </a:p>
+        </p:txBody>
+      </p:sp>
+      <p:sp>
+        <p:nvSpPr>
+          <p:cNvPr id="42" name="TextBox 41"/>
+          <p:cNvSpPr txBox="1"/>
+          <p:nvPr/>
+        </p:nvSpPr>
+        <p:spPr>
+          <a:xfrm>
+            <a:off x="7699248" y="2651760"/>
+            <a:ext cx="4206240" cy="256032"/>
+          </a:xfrm>
+          <a:prstGeom prst="rect">
+            <a:avLst/>
+          </a:prstGeom>
+          <a:noFill/>
+        </p:spPr>
+        <p:txBody>
+          <a:bodyPr wrap="square" lIns="0" tIns="0" rIns="0" bIns="0">
+            <a:spAutoFit/>
+          </a:bodyPr>
+          <a:lstStyle/>
+          <a:p>
+            <a:pPr algn="l"/>
+            <a:r>
+              <a:rPr sz="950" b="0">
+                <a:solidFill>
+                  <a:srgbClr val="334155"/>
+                </a:solidFill>
+                <a:latin typeface="Calibri"/>
+              </a:rPr>
+              <a:t>Google Gemini 2.5 Flash</a:t>
+            </a:r>
+          </a:p>
+        </p:txBody>
+      </p:sp>
+      <p:sp>
+        <p:nvSpPr>
+          <p:cNvPr id="43" name="Rounded Rectangle 42"/>
           <p:cNvSpPr/>
           <p:nvPr/>
         </p:nvSpPr>
         <p:spPr>
           <a:xfrm>
-            <a:off x="5961888" y="201168"/>
-            <a:ext cx="1499616" cy="54864"/>
-          </a:xfrm>
-          <a:prstGeom prst="rect">
+            <a:off x="5029200" y="3182112"/>
+            <a:ext cx="2560320" cy="292608"/>
+          </a:xfrm>
+          <a:prstGeom prst="roundRect">
             <a:avLst/>
           </a:prstGeom>
           <a:solidFill>
-            <a:srgbClr val="059669"/>
+            <a:srgbClr val="F0F5FC"/>
           </a:solidFill>
-          <a:ln>
-            <a:noFill/>
+          <a:ln w="6350">
+            <a:solidFill>
+              <a:srgbClr val="CBD5E1"/>
+            </a:solidFill>
           </a:ln>
         </p:spPr>
         <p:style>
@@ -3947,23 +4685,95 @@
       </p:sp>
       <p:sp>
         <p:nvSpPr>
-          <p:cNvPr id="23" name="Oval 22"/>
+          <p:cNvPr id="44" name="TextBox 43"/>
+          <p:cNvSpPr txBox="1"/>
+          <p:nvPr/>
+        </p:nvSpPr>
+        <p:spPr>
+          <a:xfrm>
+            <a:off x="5074920" y="3218688"/>
+            <a:ext cx="2468880" cy="256032"/>
+          </a:xfrm>
+          <a:prstGeom prst="rect">
+            <a:avLst/>
+          </a:prstGeom>
+          <a:noFill/>
+        </p:spPr>
+        <p:txBody>
+          <a:bodyPr wrap="square" lIns="0" tIns="0" rIns="0" bIns="0">
+            <a:spAutoFit/>
+          </a:bodyPr>
+          <a:lstStyle/>
+          <a:p>
+            <a:pPr algn="l"/>
+            <a:r>
+              <a:rPr sz="850" b="1">
+                <a:solidFill>
+                  <a:srgbClr val="1D4ED8"/>
+                </a:solidFill>
+                <a:latin typeface="Calibri"/>
+              </a:rPr>
+              <a:t>Vector Knowledge Base</a:t>
+            </a:r>
+          </a:p>
+        </p:txBody>
+      </p:sp>
+      <p:sp>
+        <p:nvSpPr>
+          <p:cNvPr id="45" name="TextBox 44"/>
+          <p:cNvSpPr txBox="1"/>
+          <p:nvPr/>
+        </p:nvSpPr>
+        <p:spPr>
+          <a:xfrm>
+            <a:off x="7699248" y="3218688"/>
+            <a:ext cx="4206240" cy="256032"/>
+          </a:xfrm>
+          <a:prstGeom prst="rect">
+            <a:avLst/>
+          </a:prstGeom>
+          <a:noFill/>
+        </p:spPr>
+        <p:txBody>
+          <a:bodyPr wrap="square" lIns="0" tIns="0" rIns="0" bIns="0">
+            <a:spAutoFit/>
+          </a:bodyPr>
+          <a:lstStyle/>
+          <a:p>
+            <a:pPr algn="l"/>
+            <a:r>
+              <a:rPr sz="950" b="0">
+                <a:solidFill>
+                  <a:srgbClr val="334155"/>
+                </a:solidFill>
+                <a:latin typeface="Calibri"/>
+              </a:rPr>
+              <a:t>ChromaDB + SEC EDGAR 10-K Filings</a:t>
+            </a:r>
+          </a:p>
+        </p:txBody>
+      </p:sp>
+      <p:sp>
+        <p:nvSpPr>
+          <p:cNvPr id="46" name="Rounded Rectangle 45"/>
           <p:cNvSpPr/>
           <p:nvPr/>
         </p:nvSpPr>
         <p:spPr>
           <a:xfrm>
-            <a:off x="6254496" y="384048"/>
-            <a:ext cx="914400" cy="914400"/>
-          </a:xfrm>
-          <a:prstGeom prst="ellipse">
+            <a:off x="5029200" y="3749040"/>
+            <a:ext cx="2560320" cy="292608"/>
+          </a:xfrm>
+          <a:prstGeom prst="roundRect">
             <a:avLst/>
           </a:prstGeom>
           <a:solidFill>
-            <a:srgbClr val="059669"/>
+            <a:srgbClr val="F0F5FC"/>
           </a:solidFill>
-          <a:ln>
-            <a:noFill/>
+          <a:ln w="6350">
+            <a:solidFill>
+              <a:srgbClr val="CBD5E1"/>
+            </a:solidFill>
           </a:ln>
         </p:spPr>
         <p:style>
@@ -3990,14 +4800,14 @@
       </p:sp>
       <p:sp>
         <p:nvSpPr>
-          <p:cNvPr id="24" name="TextBox 23"/>
+          <p:cNvPr id="47" name="TextBox 46"/>
           <p:cNvSpPr txBox="1"/>
           <p:nvPr/>
         </p:nvSpPr>
         <p:spPr>
           <a:xfrm>
-            <a:off x="6254496" y="475488"/>
-            <a:ext cx="914400" cy="347472"/>
+            <a:off x="5074920" y="3785616"/>
+            <a:ext cx="2468880" cy="256032"/>
           </a:xfrm>
           <a:prstGeom prst="rect">
             <a:avLst/>
@@ -4010,29 +4820,29 @@
           </a:bodyPr>
           <a:lstStyle/>
           <a:p>
-            <a:pPr algn="ctr"/>
-            <a:r>
-              <a:rPr sz="1400" b="1">
-                <a:solidFill>
-                  <a:srgbClr val="FFFFFF"/>
-                </a:solidFill>
-                <a:latin typeface="Calibri"/>
-              </a:rPr>
-              <a:t>SG</a:t>
-            </a:r>
-          </a:p>
-        </p:txBody>
-      </p:sp>
-      <p:sp>
-        <p:nvSpPr>
-          <p:cNvPr id="25" name="TextBox 24"/>
+            <a:pPr algn="l"/>
+            <a:r>
+              <a:rPr sz="850" b="1">
+                <a:solidFill>
+                  <a:srgbClr val="1D4ED8"/>
+                </a:solidFill>
+                <a:latin typeface="Calibri"/>
+              </a:rPr>
+              <a:t>Frontend</a:t>
+            </a:r>
+          </a:p>
+        </p:txBody>
+      </p:sp>
+      <p:sp>
+        <p:nvSpPr>
+          <p:cNvPr id="48" name="TextBox 47"/>
           <p:cNvSpPr txBox="1"/>
           <p:nvPr/>
         </p:nvSpPr>
         <p:spPr>
           <a:xfrm>
-            <a:off x="6035040" y="1426464"/>
-            <a:ext cx="1353312" cy="475488"/>
+            <a:off x="7699248" y="3785616"/>
+            <a:ext cx="4206240" cy="256032"/>
           </a:xfrm>
           <a:prstGeom prst="rect">
             <a:avLst/>
@@ -4045,38 +4855,40 @@
           </a:bodyPr>
           <a:lstStyle/>
           <a:p>
-            <a:pPr algn="ctr"/>
-            <a:r>
-              <a:rPr sz="950" b="1">
-                <a:solidFill>
-                  <a:srgbClr val="0F2040"/>
-                </a:solidFill>
-                <a:latin typeface="Calibri"/>
-              </a:rPr>
-              <a:t>Shradha Gaikwad</a:t>
-            </a:r>
-          </a:p>
-        </p:txBody>
-      </p:sp>
-      <p:sp>
-        <p:nvSpPr>
-          <p:cNvPr id="26" name="Rectangle 25"/>
+            <a:pPr algn="l"/>
+            <a:r>
+              <a:rPr sz="950" b="0">
+                <a:solidFill>
+                  <a:srgbClr val="334155"/>
+                </a:solidFill>
+                <a:latin typeface="Calibri"/>
+              </a:rPr>
+              <a:t>Streamlit 3-Tab Analyst Dashboard</a:t>
+            </a:r>
+          </a:p>
+        </p:txBody>
+      </p:sp>
+      <p:sp>
+        <p:nvSpPr>
+          <p:cNvPr id="49" name="Rounded Rectangle 48"/>
           <p:cNvSpPr/>
           <p:nvPr/>
         </p:nvSpPr>
         <p:spPr>
           <a:xfrm>
-            <a:off x="6144768" y="1938528"/>
-            <a:ext cx="1133856" cy="13716"/>
-          </a:xfrm>
-          <a:prstGeom prst="rect">
+            <a:off x="5029200" y="4315968"/>
+            <a:ext cx="2560320" cy="292608"/>
+          </a:xfrm>
+          <a:prstGeom prst="roundRect">
             <a:avLst/>
           </a:prstGeom>
           <a:solidFill>
-            <a:srgbClr val="CBD5E1"/>
+            <a:srgbClr val="F0F5FC"/>
           </a:solidFill>
-          <a:ln>
-            <a:noFill/>
+          <a:ln w="6350">
+            <a:solidFill>
+              <a:srgbClr val="CBD5E1"/>
+            </a:solidFill>
           </a:ln>
         </p:spPr>
         <p:style>
@@ -4103,14 +4915,14 @@
       </p:sp>
       <p:sp>
         <p:nvSpPr>
-          <p:cNvPr id="27" name="TextBox 26"/>
+          <p:cNvPr id="50" name="TextBox 49"/>
           <p:cNvSpPr txBox="1"/>
           <p:nvPr/>
         </p:nvSpPr>
         <p:spPr>
           <a:xfrm>
-            <a:off x="6035040" y="2029968"/>
-            <a:ext cx="1353312" cy="365760"/>
+            <a:off x="5074920" y="4352544"/>
+            <a:ext cx="2468880" cy="256032"/>
           </a:xfrm>
           <a:prstGeom prst="rect">
             <a:avLst/>
@@ -4123,38 +4935,75 @@
           </a:bodyPr>
           <a:lstStyle/>
           <a:p>
-            <a:pPr algn="ctr"/>
-            <a:r>
-              <a:rPr sz="800" b="1">
-                <a:solidFill>
-                  <a:srgbClr val="059669"/>
-                </a:solidFill>
-                <a:latin typeface="Calibri"/>
-              </a:rPr>
-              <a:t>Financial Modeling Lead</a:t>
-            </a:r>
-          </a:p>
-        </p:txBody>
-      </p:sp>
-      <p:sp>
-        <p:nvSpPr>
-          <p:cNvPr id="28" name="Rectangle 27"/>
+            <a:pPr algn="l"/>
+            <a:r>
+              <a:rPr sz="850" b="1">
+                <a:solidFill>
+                  <a:srgbClr val="1D4ED8"/>
+                </a:solidFill>
+                <a:latin typeface="Calibri"/>
+              </a:rPr>
+              <a:t>Cloud Infrastructure</a:t>
+            </a:r>
+          </a:p>
+        </p:txBody>
+      </p:sp>
+      <p:sp>
+        <p:nvSpPr>
+          <p:cNvPr id="51" name="TextBox 50"/>
+          <p:cNvSpPr txBox="1"/>
+          <p:nvPr/>
+        </p:nvSpPr>
+        <p:spPr>
+          <a:xfrm>
+            <a:off x="7699248" y="4352544"/>
+            <a:ext cx="4206240" cy="256032"/>
+          </a:xfrm>
+          <a:prstGeom prst="rect">
+            <a:avLst/>
+          </a:prstGeom>
+          <a:noFill/>
+        </p:spPr>
+        <p:txBody>
+          <a:bodyPr wrap="square" lIns="0" tIns="0" rIns="0" bIns="0">
+            <a:spAutoFit/>
+          </a:bodyPr>
+          <a:lstStyle/>
+          <a:p>
+            <a:pPr algn="l"/>
+            <a:r>
+              <a:rPr sz="950" b="0">
+                <a:solidFill>
+                  <a:srgbClr val="334155"/>
+                </a:solidFill>
+                <a:latin typeface="Calibri"/>
+              </a:rPr>
+              <a:t>AWS EC2 + S3 (Docker Containerised)</a:t>
+            </a:r>
+          </a:p>
+        </p:txBody>
+      </p:sp>
+      <p:sp>
+        <p:nvSpPr>
+          <p:cNvPr id="52" name="Rounded Rectangle 51"/>
           <p:cNvSpPr/>
           <p:nvPr/>
         </p:nvSpPr>
         <p:spPr>
           <a:xfrm>
-            <a:off x="6144768" y="2450592"/>
-            <a:ext cx="1133856" cy="13716"/>
-          </a:xfrm>
-          <a:prstGeom prst="rect">
+            <a:off x="5029200" y="4882896"/>
+            <a:ext cx="2560320" cy="292608"/>
+          </a:xfrm>
+          <a:prstGeom prst="roundRect">
             <a:avLst/>
           </a:prstGeom>
           <a:solidFill>
-            <a:srgbClr val="CBD5E1"/>
+            <a:srgbClr val="F0F5FC"/>
           </a:solidFill>
-          <a:ln>
-            <a:noFill/>
+          <a:ln w="6350">
+            <a:solidFill>
+              <a:srgbClr val="CBD5E1"/>
+            </a:solidFill>
           </a:ln>
         </p:spPr>
         <p:style>
@@ -4181,14 +5030,14 @@
       </p:sp>
       <p:sp>
         <p:nvSpPr>
-          <p:cNvPr id="29" name="TextBox 28"/>
+          <p:cNvPr id="53" name="TextBox 52"/>
           <p:cNvSpPr txBox="1"/>
           <p:nvPr/>
         </p:nvSpPr>
         <p:spPr>
           <a:xfrm>
-            <a:off x="6053328" y="2560320"/>
-            <a:ext cx="1316736" cy="1280160"/>
+            <a:off x="5074920" y="4919472"/>
+            <a:ext cx="2468880" cy="256032"/>
           </a:xfrm>
           <a:prstGeom prst="rect">
             <a:avLst/>
@@ -4201,31 +5050,64 @@
           </a:bodyPr>
           <a:lstStyle/>
           <a:p>
-            <a:pPr algn="ctr"/>
-            <a:r>
-              <a:rPr sz="800" b="0">
-                <a:solidFill>
-                  <a:srgbClr val="64748B"/>
-                </a:solidFill>
-                <a:latin typeface="Calibri"/>
-              </a:rPr>
-              <a:t>Market Research
-Summary Agent
-Pydantic Schemas</a:t>
-            </a:r>
-          </a:p>
-        </p:txBody>
-      </p:sp>
-      <p:sp>
-        <p:nvSpPr>
-          <p:cNvPr id="30" name="Rounded Rectangle 29"/>
+            <a:pPr algn="l"/>
+            <a:r>
+              <a:rPr sz="850" b="1">
+                <a:solidFill>
+                  <a:srgbClr val="1D4ED8"/>
+                </a:solidFill>
+                <a:latin typeface="Calibri"/>
+              </a:rPr>
+              <a:t>Governance Model</a:t>
+            </a:r>
+          </a:p>
+        </p:txBody>
+      </p:sp>
+      <p:sp>
+        <p:nvSpPr>
+          <p:cNvPr id="54" name="TextBox 53"/>
+          <p:cNvSpPr txBox="1"/>
+          <p:nvPr/>
+        </p:nvSpPr>
+        <p:spPr>
+          <a:xfrm>
+            <a:off x="7699248" y="4919472"/>
+            <a:ext cx="4206240" cy="256032"/>
+          </a:xfrm>
+          <a:prstGeom prst="rect">
+            <a:avLst/>
+          </a:prstGeom>
+          <a:noFill/>
+        </p:spPr>
+        <p:txBody>
+          <a:bodyPr wrap="square" lIns="0" tIns="0" rIns="0" bIns="0">
+            <a:spAutoFit/>
+          </a:bodyPr>
+          <a:lstStyle/>
+          <a:p>
+            <a:pPr algn="l"/>
+            <a:r>
+              <a:rPr sz="950" b="0">
+                <a:solidFill>
+                  <a:srgbClr val="334155"/>
+                </a:solidFill>
+                <a:latin typeface="Calibri"/>
+              </a:rPr>
+              <a:t>Human-in-the-Loop Compliance Gate</a:t>
+            </a:r>
+          </a:p>
+        </p:txBody>
+      </p:sp>
+      <p:sp>
+        <p:nvSpPr>
+          <p:cNvPr id="55" name="Rounded Rectangle 54"/>
           <p:cNvSpPr/>
           <p:nvPr/>
         </p:nvSpPr>
         <p:spPr>
           <a:xfrm>
-            <a:off x="7516368" y="201168"/>
-            <a:ext cx="1499616" cy="6455664"/>
+            <a:off x="5029200" y="5449824"/>
+            <a:ext cx="2560320" cy="292608"/>
           </a:xfrm>
           <a:prstGeom prst="roundRect">
             <a:avLst/>
@@ -4233,7 +5115,7 @@
           <a:solidFill>
             <a:srgbClr val="F0F5FC"/>
           </a:solidFill>
-          <a:ln w="9525">
+          <a:ln w="6350">
             <a:solidFill>
               <a:srgbClr val="CBD5E1"/>
             </a:solidFill>
@@ -4263,100 +5145,14 @@
       </p:sp>
       <p:sp>
         <p:nvSpPr>
-          <p:cNvPr id="31" name="Rectangle 30"/>
-          <p:cNvSpPr/>
-          <p:nvPr/>
-        </p:nvSpPr>
-        <p:spPr>
-          <a:xfrm>
-            <a:off x="7516368" y="201168"/>
-            <a:ext cx="1499616" cy="54864"/>
-          </a:xfrm>
-          <a:prstGeom prst="rect">
-            <a:avLst/>
-          </a:prstGeom>
-          <a:solidFill>
-            <a:srgbClr val="B45309"/>
-          </a:solidFill>
-          <a:ln>
-            <a:noFill/>
-          </a:ln>
-        </p:spPr>
-        <p:style>
-          <a:lnRef idx="1">
-            <a:schemeClr val="accent1"/>
-          </a:lnRef>
-          <a:fillRef idx="3">
-            <a:schemeClr val="accent1"/>
-          </a:fillRef>
-          <a:effectRef idx="2">
-            <a:schemeClr val="accent1"/>
-          </a:effectRef>
-          <a:fontRef idx="minor">
-            <a:schemeClr val="lt1"/>
-          </a:fontRef>
-        </p:style>
-        <p:txBody>
-          <a:bodyPr rtlCol="0" anchor="ctr"/>
-          <a:lstStyle/>
-          <a:p>
-            <a:pPr algn="ctr"/>
-          </a:p>
-        </p:txBody>
-      </p:sp>
-      <p:sp>
-        <p:nvSpPr>
-          <p:cNvPr id="32" name="Oval 31"/>
-          <p:cNvSpPr/>
-          <p:nvPr/>
-        </p:nvSpPr>
-        <p:spPr>
-          <a:xfrm>
-            <a:off x="7808976" y="384048"/>
-            <a:ext cx="914400" cy="914400"/>
-          </a:xfrm>
-          <a:prstGeom prst="ellipse">
-            <a:avLst/>
-          </a:prstGeom>
-          <a:solidFill>
-            <a:srgbClr val="B45309"/>
-          </a:solidFill>
-          <a:ln>
-            <a:noFill/>
-          </a:ln>
-        </p:spPr>
-        <p:style>
-          <a:lnRef idx="1">
-            <a:schemeClr val="accent1"/>
-          </a:lnRef>
-          <a:fillRef idx="3">
-            <a:schemeClr val="accent1"/>
-          </a:fillRef>
-          <a:effectRef idx="2">
-            <a:schemeClr val="accent1"/>
-          </a:effectRef>
-          <a:fontRef idx="minor">
-            <a:schemeClr val="lt1"/>
-          </a:fontRef>
-        </p:style>
-        <p:txBody>
-          <a:bodyPr rtlCol="0" anchor="ctr"/>
-          <a:lstStyle/>
-          <a:p>
-            <a:pPr algn="ctr"/>
-          </a:p>
-        </p:txBody>
-      </p:sp>
-      <p:sp>
-        <p:nvSpPr>
-          <p:cNvPr id="33" name="TextBox 32"/>
+          <p:cNvPr id="56" name="TextBox 55"/>
           <p:cNvSpPr txBox="1"/>
           <p:nvPr/>
         </p:nvSpPr>
         <p:spPr>
           <a:xfrm>
-            <a:off x="7808976" y="475488"/>
-            <a:ext cx="914400" cy="347472"/>
+            <a:off x="5074920" y="5486400"/>
+            <a:ext cx="2468880" cy="256032"/>
           </a:xfrm>
           <a:prstGeom prst="rect">
             <a:avLst/>
@@ -4369,29 +5165,29 @@
           </a:bodyPr>
           <a:lstStyle/>
           <a:p>
-            <a:pPr algn="ctr"/>
-            <a:r>
-              <a:rPr sz="1400" b="1">
-                <a:solidFill>
-                  <a:srgbClr val="FFFFFF"/>
-                </a:solidFill>
-                <a:latin typeface="Calibri"/>
-              </a:rPr>
-              <a:t>ST</a:t>
-            </a:r>
-          </a:p>
-        </p:txBody>
-      </p:sp>
-      <p:sp>
-        <p:nvSpPr>
-          <p:cNvPr id="34" name="TextBox 33"/>
+            <a:pPr algn="l"/>
+            <a:r>
+              <a:rPr sz="850" b="1">
+                <a:solidFill>
+                  <a:srgbClr val="1D4ED8"/>
+                </a:solidFill>
+                <a:latin typeface="Calibri"/>
+              </a:rPr>
+              <a:t>Data Coverage</a:t>
+            </a:r>
+          </a:p>
+        </p:txBody>
+      </p:sp>
+      <p:sp>
+        <p:nvSpPr>
+          <p:cNvPr id="57" name="TextBox 56"/>
           <p:cNvSpPr txBox="1"/>
           <p:nvPr/>
         </p:nvSpPr>
         <p:spPr>
           <a:xfrm>
-            <a:off x="7589520" y="1426464"/>
-            <a:ext cx="1353312" cy="475488"/>
+            <a:off x="7699248" y="5486400"/>
+            <a:ext cx="4206240" cy="256032"/>
           </a:xfrm>
           <a:prstGeom prst="rect">
             <a:avLst/>
@@ -4404,891 +5200,15 @@
           </a:bodyPr>
           <a:lstStyle/>
           <a:p>
-            <a:pPr algn="ctr"/>
-            <a:r>
-              <a:rPr sz="950" b="1">
-                <a:solidFill>
-                  <a:srgbClr val="0F2040"/>
-                </a:solidFill>
-                <a:latin typeface="Calibri"/>
-              </a:rPr>
-              <a:t>Sagar Trimukhe</a:t>
-            </a:r>
-          </a:p>
-        </p:txBody>
-      </p:sp>
-      <p:sp>
-        <p:nvSpPr>
-          <p:cNvPr id="35" name="Rectangle 34"/>
-          <p:cNvSpPr/>
-          <p:nvPr/>
-        </p:nvSpPr>
-        <p:spPr>
-          <a:xfrm>
-            <a:off x="7699248" y="1938528"/>
-            <a:ext cx="1133856" cy="13716"/>
-          </a:xfrm>
-          <a:prstGeom prst="rect">
-            <a:avLst/>
-          </a:prstGeom>
-          <a:solidFill>
-            <a:srgbClr val="CBD5E1"/>
-          </a:solidFill>
-          <a:ln>
-            <a:noFill/>
-          </a:ln>
-        </p:spPr>
-        <p:style>
-          <a:lnRef idx="1">
-            <a:schemeClr val="accent1"/>
-          </a:lnRef>
-          <a:fillRef idx="3">
-            <a:schemeClr val="accent1"/>
-          </a:fillRef>
-          <a:effectRef idx="2">
-            <a:schemeClr val="accent1"/>
-          </a:effectRef>
-          <a:fontRef idx="minor">
-            <a:schemeClr val="lt1"/>
-          </a:fontRef>
-        </p:style>
-        <p:txBody>
-          <a:bodyPr rtlCol="0" anchor="ctr"/>
-          <a:lstStyle/>
-          <a:p>
-            <a:pPr algn="ctr"/>
-          </a:p>
-        </p:txBody>
-      </p:sp>
-      <p:sp>
-        <p:nvSpPr>
-          <p:cNvPr id="36" name="TextBox 35"/>
-          <p:cNvSpPr txBox="1"/>
-          <p:nvPr/>
-        </p:nvSpPr>
-        <p:spPr>
-          <a:xfrm>
-            <a:off x="7589520" y="2029968"/>
-            <a:ext cx="1353312" cy="365760"/>
-          </a:xfrm>
-          <a:prstGeom prst="rect">
-            <a:avLst/>
-          </a:prstGeom>
-          <a:noFill/>
-        </p:spPr>
-        <p:txBody>
-          <a:bodyPr wrap="square" lIns="0" tIns="0" rIns="0" bIns="0">
-            <a:spAutoFit/>
-          </a:bodyPr>
-          <a:lstStyle/>
-          <a:p>
-            <a:pPr algn="ctr"/>
-            <a:r>
-              <a:rPr sz="800" b="1">
-                <a:solidFill>
-                  <a:srgbClr val="B45309"/>
-                </a:solidFill>
-                <a:latin typeface="Calibri"/>
-              </a:rPr>
-              <a:t>Frontend &amp; HITL Lead</a:t>
-            </a:r>
-          </a:p>
-        </p:txBody>
-      </p:sp>
-      <p:sp>
-        <p:nvSpPr>
-          <p:cNvPr id="37" name="Rectangle 36"/>
-          <p:cNvSpPr/>
-          <p:nvPr/>
-        </p:nvSpPr>
-        <p:spPr>
-          <a:xfrm>
-            <a:off x="7699248" y="2450592"/>
-            <a:ext cx="1133856" cy="13716"/>
-          </a:xfrm>
-          <a:prstGeom prst="rect">
-            <a:avLst/>
-          </a:prstGeom>
-          <a:solidFill>
-            <a:srgbClr val="CBD5E1"/>
-          </a:solidFill>
-          <a:ln>
-            <a:noFill/>
-          </a:ln>
-        </p:spPr>
-        <p:style>
-          <a:lnRef idx="1">
-            <a:schemeClr val="accent1"/>
-          </a:lnRef>
-          <a:fillRef idx="3">
-            <a:schemeClr val="accent1"/>
-          </a:fillRef>
-          <a:effectRef idx="2">
-            <a:schemeClr val="accent1"/>
-          </a:effectRef>
-          <a:fontRef idx="minor">
-            <a:schemeClr val="lt1"/>
-          </a:fontRef>
-        </p:style>
-        <p:txBody>
-          <a:bodyPr rtlCol="0" anchor="ctr"/>
-          <a:lstStyle/>
-          <a:p>
-            <a:pPr algn="ctr"/>
-          </a:p>
-        </p:txBody>
-      </p:sp>
-      <p:sp>
-        <p:nvSpPr>
-          <p:cNvPr id="38" name="TextBox 37"/>
-          <p:cNvSpPr txBox="1"/>
-          <p:nvPr/>
-        </p:nvSpPr>
-        <p:spPr>
-          <a:xfrm>
-            <a:off x="7607808" y="2560320"/>
-            <a:ext cx="1316736" cy="1280160"/>
-          </a:xfrm>
-          <a:prstGeom prst="rect">
-            <a:avLst/>
-          </a:prstGeom>
-          <a:noFill/>
-        </p:spPr>
-        <p:txBody>
-          <a:bodyPr wrap="square" lIns="0" tIns="0" rIns="0" bIns="0">
-            <a:spAutoFit/>
-          </a:bodyPr>
-          <a:lstStyle/>
-          <a:p>
-            <a:pPr algn="ctr"/>
-            <a:r>
-              <a:rPr sz="800" b="0">
-                <a:solidFill>
-                  <a:srgbClr val="64748B"/>
-                </a:solidFill>
-                <a:latin typeface="Calibri"/>
-              </a:rPr>
-              <a:t>Streamlit UI
-Docker
-S3 Export</a:t>
-            </a:r>
-          </a:p>
-        </p:txBody>
-      </p:sp>
-      <p:sp>
-        <p:nvSpPr>
-          <p:cNvPr id="39" name="Rounded Rectangle 38"/>
-          <p:cNvSpPr/>
-          <p:nvPr/>
-        </p:nvSpPr>
-        <p:spPr>
-          <a:xfrm>
-            <a:off x="9070848" y="201168"/>
-            <a:ext cx="1499616" cy="6455664"/>
-          </a:xfrm>
-          <a:prstGeom prst="roundRect">
-            <a:avLst/>
-          </a:prstGeom>
-          <a:solidFill>
-            <a:srgbClr val="F0F5FC"/>
-          </a:solidFill>
-          <a:ln w="9525">
-            <a:solidFill>
-              <a:srgbClr val="CBD5E1"/>
-            </a:solidFill>
-          </a:ln>
-        </p:spPr>
-        <p:style>
-          <a:lnRef idx="1">
-            <a:schemeClr val="accent1"/>
-          </a:lnRef>
-          <a:fillRef idx="3">
-            <a:schemeClr val="accent1"/>
-          </a:fillRef>
-          <a:effectRef idx="2">
-            <a:schemeClr val="accent1"/>
-          </a:effectRef>
-          <a:fontRef idx="minor">
-            <a:schemeClr val="lt1"/>
-          </a:fontRef>
-        </p:style>
-        <p:txBody>
-          <a:bodyPr rtlCol="0" anchor="ctr"/>
-          <a:lstStyle/>
-          <a:p>
-            <a:pPr algn="ctr"/>
-          </a:p>
-        </p:txBody>
-      </p:sp>
-      <p:sp>
-        <p:nvSpPr>
-          <p:cNvPr id="40" name="Rectangle 39"/>
-          <p:cNvSpPr/>
-          <p:nvPr/>
-        </p:nvSpPr>
-        <p:spPr>
-          <a:xfrm>
-            <a:off x="9070848" y="201168"/>
-            <a:ext cx="1499616" cy="54864"/>
-          </a:xfrm>
-          <a:prstGeom prst="rect">
-            <a:avLst/>
-          </a:prstGeom>
-          <a:solidFill>
-            <a:srgbClr val="6D28D9"/>
-          </a:solidFill>
-          <a:ln>
-            <a:noFill/>
-          </a:ln>
-        </p:spPr>
-        <p:style>
-          <a:lnRef idx="1">
-            <a:schemeClr val="accent1"/>
-          </a:lnRef>
-          <a:fillRef idx="3">
-            <a:schemeClr val="accent1"/>
-          </a:fillRef>
-          <a:effectRef idx="2">
-            <a:schemeClr val="accent1"/>
-          </a:effectRef>
-          <a:fontRef idx="minor">
-            <a:schemeClr val="lt1"/>
-          </a:fontRef>
-        </p:style>
-        <p:txBody>
-          <a:bodyPr rtlCol="0" anchor="ctr"/>
-          <a:lstStyle/>
-          <a:p>
-            <a:pPr algn="ctr"/>
-          </a:p>
-        </p:txBody>
-      </p:sp>
-      <p:sp>
-        <p:nvSpPr>
-          <p:cNvPr id="41" name="Oval 40"/>
-          <p:cNvSpPr/>
-          <p:nvPr/>
-        </p:nvSpPr>
-        <p:spPr>
-          <a:xfrm>
-            <a:off x="9363456" y="384048"/>
-            <a:ext cx="914400" cy="914400"/>
-          </a:xfrm>
-          <a:prstGeom prst="ellipse">
-            <a:avLst/>
-          </a:prstGeom>
-          <a:solidFill>
-            <a:srgbClr val="6D28D9"/>
-          </a:solidFill>
-          <a:ln>
-            <a:noFill/>
-          </a:ln>
-        </p:spPr>
-        <p:style>
-          <a:lnRef idx="1">
-            <a:schemeClr val="accent1"/>
-          </a:lnRef>
-          <a:fillRef idx="3">
-            <a:schemeClr val="accent1"/>
-          </a:fillRef>
-          <a:effectRef idx="2">
-            <a:schemeClr val="accent1"/>
-          </a:effectRef>
-          <a:fontRef idx="minor">
-            <a:schemeClr val="lt1"/>
-          </a:fontRef>
-        </p:style>
-        <p:txBody>
-          <a:bodyPr rtlCol="0" anchor="ctr"/>
-          <a:lstStyle/>
-          <a:p>
-            <a:pPr algn="ctr"/>
-          </a:p>
-        </p:txBody>
-      </p:sp>
-      <p:sp>
-        <p:nvSpPr>
-          <p:cNvPr id="42" name="TextBox 41"/>
-          <p:cNvSpPr txBox="1"/>
-          <p:nvPr/>
-        </p:nvSpPr>
-        <p:spPr>
-          <a:xfrm>
-            <a:off x="9363456" y="475488"/>
-            <a:ext cx="914400" cy="347472"/>
-          </a:xfrm>
-          <a:prstGeom prst="rect">
-            <a:avLst/>
-          </a:prstGeom>
-          <a:noFill/>
-        </p:spPr>
-        <p:txBody>
-          <a:bodyPr wrap="square" lIns="0" tIns="0" rIns="0" bIns="0">
-            <a:spAutoFit/>
-          </a:bodyPr>
-          <a:lstStyle/>
-          <a:p>
-            <a:pPr algn="ctr"/>
-            <a:r>
-              <a:rPr sz="1400" b="1">
-                <a:solidFill>
-                  <a:srgbClr val="FFFFFF"/>
-                </a:solidFill>
-                <a:latin typeface="Calibri"/>
-              </a:rPr>
-              <a:t>ND</a:t>
-            </a:r>
-          </a:p>
-        </p:txBody>
-      </p:sp>
-      <p:sp>
-        <p:nvSpPr>
-          <p:cNvPr id="43" name="TextBox 42"/>
-          <p:cNvSpPr txBox="1"/>
-          <p:nvPr/>
-        </p:nvSpPr>
-        <p:spPr>
-          <a:xfrm>
-            <a:off x="9144000" y="1426464"/>
-            <a:ext cx="1353312" cy="475488"/>
-          </a:xfrm>
-          <a:prstGeom prst="rect">
-            <a:avLst/>
-          </a:prstGeom>
-          <a:noFill/>
-        </p:spPr>
-        <p:txBody>
-          <a:bodyPr wrap="square" lIns="0" tIns="0" rIns="0" bIns="0">
-            <a:spAutoFit/>
-          </a:bodyPr>
-          <a:lstStyle/>
-          <a:p>
-            <a:pPr algn="ctr"/>
-            <a:r>
-              <a:rPr sz="950" b="1">
-                <a:solidFill>
-                  <a:srgbClr val="0F2040"/>
-                </a:solidFill>
-                <a:latin typeface="Calibri"/>
-              </a:rPr>
-              <a:t>Nilanjan Das</a:t>
-            </a:r>
-          </a:p>
-        </p:txBody>
-      </p:sp>
-      <p:sp>
-        <p:nvSpPr>
-          <p:cNvPr id="44" name="Rectangle 43"/>
-          <p:cNvSpPr/>
-          <p:nvPr/>
-        </p:nvSpPr>
-        <p:spPr>
-          <a:xfrm>
-            <a:off x="9253728" y="1938528"/>
-            <a:ext cx="1133856" cy="13716"/>
-          </a:xfrm>
-          <a:prstGeom prst="rect">
-            <a:avLst/>
-          </a:prstGeom>
-          <a:solidFill>
-            <a:srgbClr val="CBD5E1"/>
-          </a:solidFill>
-          <a:ln>
-            <a:noFill/>
-          </a:ln>
-        </p:spPr>
-        <p:style>
-          <a:lnRef idx="1">
-            <a:schemeClr val="accent1"/>
-          </a:lnRef>
-          <a:fillRef idx="3">
-            <a:schemeClr val="accent1"/>
-          </a:fillRef>
-          <a:effectRef idx="2">
-            <a:schemeClr val="accent1"/>
-          </a:effectRef>
-          <a:fontRef idx="minor">
-            <a:schemeClr val="lt1"/>
-          </a:fontRef>
-        </p:style>
-        <p:txBody>
-          <a:bodyPr rtlCol="0" anchor="ctr"/>
-          <a:lstStyle/>
-          <a:p>
-            <a:pPr algn="ctr"/>
-          </a:p>
-        </p:txBody>
-      </p:sp>
-      <p:sp>
-        <p:nvSpPr>
-          <p:cNvPr id="45" name="TextBox 44"/>
-          <p:cNvSpPr txBox="1"/>
-          <p:nvPr/>
-        </p:nvSpPr>
-        <p:spPr>
-          <a:xfrm>
-            <a:off x="9144000" y="2029968"/>
-            <a:ext cx="1353312" cy="365760"/>
-          </a:xfrm>
-          <a:prstGeom prst="rect">
-            <a:avLst/>
-          </a:prstGeom>
-          <a:noFill/>
-        </p:spPr>
-        <p:txBody>
-          <a:bodyPr wrap="square" lIns="0" tIns="0" rIns="0" bIns="0">
-            <a:spAutoFit/>
-          </a:bodyPr>
-          <a:lstStyle/>
-          <a:p>
-            <a:pPr algn="ctr"/>
-            <a:r>
-              <a:rPr sz="800" b="1">
-                <a:solidFill>
-                  <a:srgbClr val="6D28D9"/>
-                </a:solidFill>
-                <a:latin typeface="Calibri"/>
-              </a:rPr>
-              <a:t>Data Engineering Lead</a:t>
-            </a:r>
-          </a:p>
-        </p:txBody>
-      </p:sp>
-      <p:sp>
-        <p:nvSpPr>
-          <p:cNvPr id="46" name="Rectangle 45"/>
-          <p:cNvSpPr/>
-          <p:nvPr/>
-        </p:nvSpPr>
-        <p:spPr>
-          <a:xfrm>
-            <a:off x="9253728" y="2450592"/>
-            <a:ext cx="1133856" cy="13716"/>
-          </a:xfrm>
-          <a:prstGeom prst="rect">
-            <a:avLst/>
-          </a:prstGeom>
-          <a:solidFill>
-            <a:srgbClr val="CBD5E1"/>
-          </a:solidFill>
-          <a:ln>
-            <a:noFill/>
-          </a:ln>
-        </p:spPr>
-        <p:style>
-          <a:lnRef idx="1">
-            <a:schemeClr val="accent1"/>
-          </a:lnRef>
-          <a:fillRef idx="3">
-            <a:schemeClr val="accent1"/>
-          </a:fillRef>
-          <a:effectRef idx="2">
-            <a:schemeClr val="accent1"/>
-          </a:effectRef>
-          <a:fontRef idx="minor">
-            <a:schemeClr val="lt1"/>
-          </a:fontRef>
-        </p:style>
-        <p:txBody>
-          <a:bodyPr rtlCol="0" anchor="ctr"/>
-          <a:lstStyle/>
-          <a:p>
-            <a:pPr algn="ctr"/>
-          </a:p>
-        </p:txBody>
-      </p:sp>
-      <p:sp>
-        <p:nvSpPr>
-          <p:cNvPr id="47" name="TextBox 46"/>
-          <p:cNvSpPr txBox="1"/>
-          <p:nvPr/>
-        </p:nvSpPr>
-        <p:spPr>
-          <a:xfrm>
-            <a:off x="9162288" y="2560320"/>
-            <a:ext cx="1316736" cy="1280160"/>
-          </a:xfrm>
-          <a:prstGeom prst="rect">
-            <a:avLst/>
-          </a:prstGeom>
-          <a:noFill/>
-        </p:spPr>
-        <p:txBody>
-          <a:bodyPr wrap="square" lIns="0" tIns="0" rIns="0" bIns="0">
-            <a:spAutoFit/>
-          </a:bodyPr>
-          <a:lstStyle/>
-          <a:p>
-            <a:pPr algn="ctr"/>
-            <a:r>
-              <a:rPr sz="800" b="0">
-                <a:solidFill>
-                  <a:srgbClr val="64748B"/>
-                </a:solidFill>
-                <a:latin typeface="Calibri"/>
-              </a:rPr>
-              <a:t>SEC EDGAR
-ChromaDB
-RAG Pipeline</a:t>
-            </a:r>
-          </a:p>
-        </p:txBody>
-      </p:sp>
-      <p:sp>
-        <p:nvSpPr>
-          <p:cNvPr id="48" name="Rounded Rectangle 47"/>
-          <p:cNvSpPr/>
-          <p:nvPr/>
-        </p:nvSpPr>
-        <p:spPr>
-          <a:xfrm>
-            <a:off x="10625328" y="201168"/>
-            <a:ext cx="1499616" cy="6455664"/>
-          </a:xfrm>
-          <a:prstGeom prst="roundRect">
-            <a:avLst/>
-          </a:prstGeom>
-          <a:solidFill>
-            <a:srgbClr val="F0F5FC"/>
-          </a:solidFill>
-          <a:ln w="9525">
-            <a:solidFill>
-              <a:srgbClr val="CBD5E1"/>
-            </a:solidFill>
-          </a:ln>
-        </p:spPr>
-        <p:style>
-          <a:lnRef idx="1">
-            <a:schemeClr val="accent1"/>
-          </a:lnRef>
-          <a:fillRef idx="3">
-            <a:schemeClr val="accent1"/>
-          </a:fillRef>
-          <a:effectRef idx="2">
-            <a:schemeClr val="accent1"/>
-          </a:effectRef>
-          <a:fontRef idx="minor">
-            <a:schemeClr val="lt1"/>
-          </a:fontRef>
-        </p:style>
-        <p:txBody>
-          <a:bodyPr rtlCol="0" anchor="ctr"/>
-          <a:lstStyle/>
-          <a:p>
-            <a:pPr algn="ctr"/>
-          </a:p>
-        </p:txBody>
-      </p:sp>
-      <p:sp>
-        <p:nvSpPr>
-          <p:cNvPr id="49" name="Rectangle 48"/>
-          <p:cNvSpPr/>
-          <p:nvPr/>
-        </p:nvSpPr>
-        <p:spPr>
-          <a:xfrm>
-            <a:off x="10625328" y="201168"/>
-            <a:ext cx="1499616" cy="54864"/>
-          </a:xfrm>
-          <a:prstGeom prst="rect">
-            <a:avLst/>
-          </a:prstGeom>
-          <a:solidFill>
-            <a:srgbClr val="334155"/>
-          </a:solidFill>
-          <a:ln>
-            <a:noFill/>
-          </a:ln>
-        </p:spPr>
-        <p:style>
-          <a:lnRef idx="1">
-            <a:schemeClr val="accent1"/>
-          </a:lnRef>
-          <a:fillRef idx="3">
-            <a:schemeClr val="accent1"/>
-          </a:fillRef>
-          <a:effectRef idx="2">
-            <a:schemeClr val="accent1"/>
-          </a:effectRef>
-          <a:fontRef idx="minor">
-            <a:schemeClr val="lt1"/>
-          </a:fontRef>
-        </p:style>
-        <p:txBody>
-          <a:bodyPr rtlCol="0" anchor="ctr"/>
-          <a:lstStyle/>
-          <a:p>
-            <a:pPr algn="ctr"/>
-          </a:p>
-        </p:txBody>
-      </p:sp>
-      <p:sp>
-        <p:nvSpPr>
-          <p:cNvPr id="50" name="Oval 49"/>
-          <p:cNvSpPr/>
-          <p:nvPr/>
-        </p:nvSpPr>
-        <p:spPr>
-          <a:xfrm>
-            <a:off x="10917936" y="384048"/>
-            <a:ext cx="914400" cy="914400"/>
-          </a:xfrm>
-          <a:prstGeom prst="ellipse">
-            <a:avLst/>
-          </a:prstGeom>
-          <a:solidFill>
-            <a:srgbClr val="334155"/>
-          </a:solidFill>
-          <a:ln>
-            <a:noFill/>
-          </a:ln>
-        </p:spPr>
-        <p:style>
-          <a:lnRef idx="1">
-            <a:schemeClr val="accent1"/>
-          </a:lnRef>
-          <a:fillRef idx="3">
-            <a:schemeClr val="accent1"/>
-          </a:fillRef>
-          <a:effectRef idx="2">
-            <a:schemeClr val="accent1"/>
-          </a:effectRef>
-          <a:fontRef idx="minor">
-            <a:schemeClr val="lt1"/>
-          </a:fontRef>
-        </p:style>
-        <p:txBody>
-          <a:bodyPr rtlCol="0" anchor="ctr"/>
-          <a:lstStyle/>
-          <a:p>
-            <a:pPr algn="ctr"/>
-          </a:p>
-        </p:txBody>
-      </p:sp>
-      <p:sp>
-        <p:nvSpPr>
-          <p:cNvPr id="51" name="TextBox 50"/>
-          <p:cNvSpPr txBox="1"/>
-          <p:nvPr/>
-        </p:nvSpPr>
-        <p:spPr>
-          <a:xfrm>
-            <a:off x="10917936" y="475488"/>
-            <a:ext cx="914400" cy="347472"/>
-          </a:xfrm>
-          <a:prstGeom prst="rect">
-            <a:avLst/>
-          </a:prstGeom>
-          <a:noFill/>
-        </p:spPr>
-        <p:txBody>
-          <a:bodyPr wrap="square" lIns="0" tIns="0" rIns="0" bIns="0">
-            <a:spAutoFit/>
-          </a:bodyPr>
-          <a:lstStyle/>
-          <a:p>
-            <a:pPr algn="ctr"/>
-            <a:r>
-              <a:rPr sz="1400" b="1">
-                <a:solidFill>
-                  <a:srgbClr val="FFFFFF"/>
-                </a:solidFill>
-                <a:latin typeface="Calibri"/>
-              </a:rPr>
-              <a:t>NG</a:t>
-            </a:r>
-          </a:p>
-        </p:txBody>
-      </p:sp>
-      <p:sp>
-        <p:nvSpPr>
-          <p:cNvPr id="52" name="TextBox 51"/>
-          <p:cNvSpPr txBox="1"/>
-          <p:nvPr/>
-        </p:nvSpPr>
-        <p:spPr>
-          <a:xfrm>
-            <a:off x="10698480" y="1426464"/>
-            <a:ext cx="1353312" cy="475488"/>
-          </a:xfrm>
-          <a:prstGeom prst="rect">
-            <a:avLst/>
-          </a:prstGeom>
-          <a:noFill/>
-        </p:spPr>
-        <p:txBody>
-          <a:bodyPr wrap="square" lIns="0" tIns="0" rIns="0" bIns="0">
-            <a:spAutoFit/>
-          </a:bodyPr>
-          <a:lstStyle/>
-          <a:p>
-            <a:pPr algn="ctr"/>
-            <a:r>
-              <a:rPr sz="950" b="1">
-                <a:solidFill>
-                  <a:srgbClr val="0F2040"/>
-                </a:solidFill>
-                <a:latin typeface="Calibri"/>
-              </a:rPr>
-              <a:t>Nikhil Gaikwad</a:t>
-            </a:r>
-          </a:p>
-        </p:txBody>
-      </p:sp>
-      <p:sp>
-        <p:nvSpPr>
-          <p:cNvPr id="53" name="Rectangle 52"/>
-          <p:cNvSpPr/>
-          <p:nvPr/>
-        </p:nvSpPr>
-        <p:spPr>
-          <a:xfrm>
-            <a:off x="10808208" y="1938528"/>
-            <a:ext cx="1133856" cy="13716"/>
-          </a:xfrm>
-          <a:prstGeom prst="rect">
-            <a:avLst/>
-          </a:prstGeom>
-          <a:solidFill>
-            <a:srgbClr val="CBD5E1"/>
-          </a:solidFill>
-          <a:ln>
-            <a:noFill/>
-          </a:ln>
-        </p:spPr>
-        <p:style>
-          <a:lnRef idx="1">
-            <a:schemeClr val="accent1"/>
-          </a:lnRef>
-          <a:fillRef idx="3">
-            <a:schemeClr val="accent1"/>
-          </a:fillRef>
-          <a:effectRef idx="2">
-            <a:schemeClr val="accent1"/>
-          </a:effectRef>
-          <a:fontRef idx="minor">
-            <a:schemeClr val="lt1"/>
-          </a:fontRef>
-        </p:style>
-        <p:txBody>
-          <a:bodyPr rtlCol="0" anchor="ctr"/>
-          <a:lstStyle/>
-          <a:p>
-            <a:pPr algn="ctr"/>
-          </a:p>
-        </p:txBody>
-      </p:sp>
-      <p:sp>
-        <p:nvSpPr>
-          <p:cNvPr id="54" name="TextBox 53"/>
-          <p:cNvSpPr txBox="1"/>
-          <p:nvPr/>
-        </p:nvSpPr>
-        <p:spPr>
-          <a:xfrm>
-            <a:off x="10698480" y="2029968"/>
-            <a:ext cx="1353312" cy="365760"/>
-          </a:xfrm>
-          <a:prstGeom prst="rect">
-            <a:avLst/>
-          </a:prstGeom>
-          <a:noFill/>
-        </p:spPr>
-        <p:txBody>
-          <a:bodyPr wrap="square" lIns="0" tIns="0" rIns="0" bIns="0">
-            <a:spAutoFit/>
-          </a:bodyPr>
-          <a:lstStyle/>
-          <a:p>
-            <a:pPr algn="ctr"/>
-            <a:r>
-              <a:rPr sz="800" b="1">
+            <a:pPr algn="l"/>
+            <a:r>
+              <a:rPr sz="950" b="0">
                 <a:solidFill>
                   <a:srgbClr val="334155"/>
                 </a:solidFill>
                 <a:latin typeface="Calibri"/>
               </a:rPr>
-              <a:t>Integration &amp; QA Lead</a:t>
-            </a:r>
-          </a:p>
-        </p:txBody>
-      </p:sp>
-      <p:sp>
-        <p:nvSpPr>
-          <p:cNvPr id="55" name="Rectangle 54"/>
-          <p:cNvSpPr/>
-          <p:nvPr/>
-        </p:nvSpPr>
-        <p:spPr>
-          <a:xfrm>
-            <a:off x="10808208" y="2450592"/>
-            <a:ext cx="1133856" cy="13716"/>
-          </a:xfrm>
-          <a:prstGeom prst="rect">
-            <a:avLst/>
-          </a:prstGeom>
-          <a:solidFill>
-            <a:srgbClr val="CBD5E1"/>
-          </a:solidFill>
-          <a:ln>
-            <a:noFill/>
-          </a:ln>
-        </p:spPr>
-        <p:style>
-          <a:lnRef idx="1">
-            <a:schemeClr val="accent1"/>
-          </a:lnRef>
-          <a:fillRef idx="3">
-            <a:schemeClr val="accent1"/>
-          </a:fillRef>
-          <a:effectRef idx="2">
-            <a:schemeClr val="accent1"/>
-          </a:effectRef>
-          <a:fontRef idx="minor">
-            <a:schemeClr val="lt1"/>
-          </a:fontRef>
-        </p:style>
-        <p:txBody>
-          <a:bodyPr rtlCol="0" anchor="ctr"/>
-          <a:lstStyle/>
-          <a:p>
-            <a:pPr algn="ctr"/>
-          </a:p>
-        </p:txBody>
-      </p:sp>
-      <p:sp>
-        <p:nvSpPr>
-          <p:cNvPr id="56" name="TextBox 55"/>
-          <p:cNvSpPr txBox="1"/>
-          <p:nvPr/>
-        </p:nvSpPr>
-        <p:spPr>
-          <a:xfrm>
-            <a:off x="10716768" y="2560320"/>
-            <a:ext cx="1316736" cy="1280160"/>
-          </a:xfrm>
-          <a:prstGeom prst="rect">
-            <a:avLst/>
-          </a:prstGeom>
-          <a:noFill/>
-        </p:spPr>
-        <p:txBody>
-          <a:bodyPr wrap="square" lIns="0" tIns="0" rIns="0" bIns="0">
-            <a:spAutoFit/>
-          </a:bodyPr>
-          <a:lstStyle/>
-          <a:p>
-            <a:pPr algn="ctr"/>
-            <a:r>
-              <a:rPr sz="800" b="0">
-                <a:solidFill>
-                  <a:srgbClr val="64748B"/>
-                </a:solidFill>
-                <a:latin typeface="Calibri"/>
-              </a:rPr>
-              <a:t>yfinance
-Rate Limiter
-Test Suite</a:t>
+              <a:t>270-Stock NASDAQ Universe</a:t>
             </a:r>
           </a:p>
         </p:txBody>

</xml_diff>

<commit_message>
docs: changes in presentation files
</commit_message>
<xml_diff>
--- a/CAPSTONE_PROJECT_PRESENTATION.pptx
+++ b/CAPSTONE_PROJECT_PRESENTATION.pptx
@@ -3221,7 +3221,7 @@
                 </a:solidFill>
                 <a:latin typeface="Calibri"/>
               </a:rPr>
-              <a:t>AUTONOMOUS EQUITY INTELLIGENCE PLATFORM  ·  Platform Architecture</a:t>
+              <a:t>AUTONOMOUS EQUITY INTELLIGENCE PLATFORM</a:t>
             </a:r>
           </a:p>
         </p:txBody>
@@ -3256,7 +3256,7 @@
                 </a:solidFill>
                 <a:latin typeface="Calibri"/>
               </a:rPr>
-              <a:t>Advanced PG Certification in AI Engineering on Cloud &amp; AIOps  ·  Capstone Final Defense</a:t>
+              <a:t>Autonomous Multi-Agent Architecture &amp; Financial Modeling  ·  Capstone Final Defense</a:t>
             </a:r>
           </a:p>
         </p:txBody>
@@ -3930,7 +3930,7 @@
                 </a:solidFill>
                 <a:latin typeface="Calibri"/>
               </a:rPr>
-              <a:t>AUTONOMOUS EQUITY INTELLIGENCE PLATFORM  ·  AI Investment Research Assistant</a:t>
+              <a:t>Enterprise Multi-Agent Equity Research  ·  AI Investment Research Assistant</a:t>
             </a:r>
           </a:p>
         </p:txBody>
@@ -4295,7 +4295,7 @@
                 </a:solidFill>
                 <a:latin typeface="Calibri"/>
               </a:rPr>
-              <a:t>AUTONOMOUS EQUITY INTELLIGENCE PLATFORM  ·  AI Investment Research Assistant</a:t>
+              <a:t>Enterprise Multi-Agent Equity Research  ·  AI Investment Research Assistant</a:t>
             </a:r>
           </a:p>
         </p:txBody>
@@ -5114,7 +5114,7 @@
                 </a:solidFill>
                 <a:latin typeface="Calibri"/>
               </a:rPr>
-              <a:t>AUTONOMOUS EQUITY INTELLIGENCE PLATFORM  ·  AI Investment Research Assistant</a:t>
+              <a:t>Enterprise Multi-Agent Equity Research  ·  AI Investment Research Assistant</a:t>
             </a:r>
           </a:p>
         </p:txBody>
@@ -5479,7 +5479,7 @@
                 </a:solidFill>
                 <a:latin typeface="Calibri"/>
               </a:rPr>
-              <a:t>AUTONOMOUS EQUITY INTELLIGENCE PLATFORM  ·  AI Investment Research Assistant</a:t>
+              <a:t>Enterprise Multi-Agent Equity Research  ·  AI Investment Research Assistant</a:t>
             </a:r>
           </a:p>
         </p:txBody>
@@ -6224,7 +6224,7 @@
                 </a:solidFill>
                 <a:latin typeface="Calibri"/>
               </a:rPr>
-              <a:t>AUTONOMOUS EQUITY INTELLIGENCE PLATFORM  ·  AI Investment Research Assistant</a:t>
+              <a:t>Enterprise Multi-Agent Equity Research  ·  AI Investment Research Assistant</a:t>
             </a:r>
           </a:p>
         </p:txBody>
@@ -6589,7 +6589,7 @@
                 </a:solidFill>
                 <a:latin typeface="Calibri"/>
               </a:rPr>
-              <a:t>AUTONOMOUS EQUITY INTELLIGENCE PLATFORM  ·  AI Investment Research Assistant</a:t>
+              <a:t>Enterprise Multi-Agent Equity Research  ·  AI Investment Research Assistant</a:t>
             </a:r>
           </a:p>
         </p:txBody>
@@ -8406,7 +8406,7 @@
                 </a:solidFill>
                 <a:latin typeface="Calibri"/>
               </a:rPr>
-              <a:t>AUTONOMOUS EQUITY INTELLIGENCE PLATFORM  ·  AI Investment Research Assistant</a:t>
+              <a:t>Enterprise Multi-Agent Equity Research  ·  AI Investment Research Assistant</a:t>
             </a:r>
           </a:p>
         </p:txBody>
@@ -8771,7 +8771,7 @@
                 </a:solidFill>
                 <a:latin typeface="Calibri"/>
               </a:rPr>
-              <a:t>AUTONOMOUS EQUITY INTELLIGENCE PLATFORM  ·  AI Investment Research Assistant</a:t>
+              <a:t>Enterprise Multi-Agent Equity Research  ·  AI Investment Research Assistant</a:t>
             </a:r>
           </a:p>
         </p:txBody>
@@ -10225,7 +10225,7 @@
                 </a:solidFill>
                 <a:latin typeface="Calibri"/>
               </a:rPr>
-              <a:t>AUTONOMOUS EQUITY INTELLIGENCE PLATFORM  ·  AI Investment Research Assistant</a:t>
+              <a:t>Enterprise Multi-Agent Equity Research  ·  AI Investment Research Assistant</a:t>
             </a:r>
           </a:p>
         </p:txBody>
@@ -11726,7 +11726,7 @@
                 </a:solidFill>
                 <a:latin typeface="Calibri"/>
               </a:rPr>
-              <a:t>AUTONOMOUS EQUITY INTELLIGENCE PLATFORM  ·  AI Investment Research Assistant</a:t>
+              <a:t>Enterprise Multi-Agent Equity Research  ·  AI Investment Research Assistant</a:t>
             </a:r>
           </a:p>
         </p:txBody>
@@ -12471,7 +12471,7 @@
                 </a:solidFill>
                 <a:latin typeface="Calibri"/>
               </a:rPr>
-              <a:t>AUTONOMOUS EQUITY INTELLIGENCE PLATFORM  ·  AI Investment Research Assistant</a:t>
+              <a:t>Enterprise Multi-Agent Equity Research  ·  AI Investment Research Assistant</a:t>
             </a:r>
           </a:p>
         </p:txBody>
@@ -12836,7 +12836,7 @@
                 </a:solidFill>
                 <a:latin typeface="Calibri"/>
               </a:rPr>
-              <a:t>AUTONOMOUS EQUITY INTELLIGENCE PLATFORM  ·  AI Investment Research Assistant</a:t>
+              <a:t>Enterprise Multi-Agent Equity Research  ·  AI Investment Research Assistant</a:t>
             </a:r>
           </a:p>
         </p:txBody>
@@ -13581,7 +13581,7 @@
                 </a:solidFill>
                 <a:latin typeface="Calibri"/>
               </a:rPr>
-              <a:t>AUTONOMOUS EQUITY INTELLIGENCE PLATFORM  ·  AI Investment Research Assistant</a:t>
+              <a:t>Enterprise Multi-Agent Equity Research  ·  AI Investment Research Assistant</a:t>
             </a:r>
           </a:p>
         </p:txBody>
@@ -13946,7 +13946,7 @@
                 </a:solidFill>
                 <a:latin typeface="Calibri"/>
               </a:rPr>
-              <a:t>AUTONOMOUS EQUITY INTELLIGENCE PLATFORM  ·  AI Investment Research Assistant</a:t>
+              <a:t>Enterprise Multi-Agent Equity Research  ·  AI Investment Research Assistant</a:t>
             </a:r>
           </a:p>
         </p:txBody>
@@ -14728,7 +14728,7 @@
                 </a:solidFill>
                 <a:latin typeface="Calibri"/>
               </a:rPr>
-              <a:t>AUTONOMOUS EQUITY INTELLIGENCE PLATFORM  ·  AI Investment Research Assistant</a:t>
+              <a:t>Enterprise Multi-Agent Equity Research  ·  AI Investment Research Assistant</a:t>
             </a:r>
           </a:p>
         </p:txBody>
@@ -15726,7 +15726,7 @@
                 </a:solidFill>
                 <a:latin typeface="Calibri"/>
               </a:rPr>
-              <a:t>AUTONOMOUS EQUITY INTELLIGENCE PLATFORM  ·  AI Investment Research Assistant</a:t>
+              <a:t>Enterprise Multi-Agent Equity Research  ·  AI Investment Research Assistant</a:t>
             </a:r>
           </a:p>
         </p:txBody>
@@ -16091,7 +16091,7 @@
                 </a:solidFill>
                 <a:latin typeface="Calibri"/>
               </a:rPr>
-              <a:t>AUTONOMOUS EQUITY INTELLIGENCE PLATFORM  ·  AI Investment Research Assistant</a:t>
+              <a:t>Enterprise Multi-Agent Equity Research  ·  AI Investment Research Assistant</a:t>
             </a:r>
           </a:p>
         </p:txBody>
@@ -16836,7 +16836,7 @@
                 </a:solidFill>
                 <a:latin typeface="Calibri"/>
               </a:rPr>
-              <a:t>AUTONOMOUS EQUITY INTELLIGENCE PLATFORM  ·  AI Investment Research Assistant</a:t>
+              <a:t>Enterprise Multi-Agent Equity Research  ·  AI Investment Research Assistant</a:t>
             </a:r>
           </a:p>
         </p:txBody>

</xml_diff>